<commit_message>
Slide 3: add the federal rules (verified), drop the phase-two line
Co-Authored-By: Claude Sonnet 5.5 <noreply@anthropic.com>
</commit_message>
<xml_diff>
--- a/deck/journey/Friction_Click_Through.pptx
+++ b/deck/journey/Friction_Click_Through.pptx
@@ -503,12 +503,16 @@
             <a:r>
               <a:rPr lang="en-US" dirty="0"/>
               <a:t>One slide. Click once per friction point. Finish your talking point, then click.
-Click 1: First, reading by hand. The nurse reads all fourteen pages to find the same few facts. The brief says it plainly: clear-cut cases take almost as long as the hard ones, because the reading and matching still happen by hand.
+Click 1: First, reading by hand. The nurse reads all fourteen pages to find the same few facts. The brief says clear-cut cases take almost as long as the hard ones, because the reading and matching still happen by hand.
 Click 2: Second, messy input. Packets come in by fax or portal, and format and quality change from one office to the next. Intake and the nurse inherit that.
-Click 3: Third, hunting instead of deciding. Benefits, eligibility, clinical policy, and provider systems sit in different places. No one view holds the full picture, so people spend their time looking, not judging.
-Click 4: Fourth, decisions vary. Two reviewers can read the same packet and land in different places. That is a fairness problem for the member and a trust problem for the provider.
-Click 5: Fifth, the pend loop. In John Doe's case, a detail a cleaner read could have caught in minutes sends the packet back to the provider. The case starts from zero, and the clock keeps running. This is the path you just watched.
-Click 6: Sixth, the member in the dark. John Doe waits for surgery and cannot see where his request stands. We name this one on purpose, and we fix it in phase two. The honest answer to 'why not now?': a member-facing status is only as good as the decision data behind it, so we build the trusted decision record first. It also touches member communications and a regulated status interface, which need their own compliance and security review. And the record we build in phase one is exactly what phase two reads from, so waiting costs us nothing.</a:t>
+Click 3: Third, hunting instead of deciding. Benefits, eligibility, clinical policy, and provider systems sit in different places. No one view holds the full picture.
+Click 4: Fourth, decisions vary. Two reviewers can read the same packet and land in different places.
+Click 5: Fifth, the pend loop. A detail a cleaner read could have caught in minutes sends the packet back to the provider. The case starts from zero. This is the path you just watched.
+Click 6: Sixth, the member in the dark. John Doe waits for surgery and cannot see where his request stands. I am not trying to solve that one first. I will come back to it.
+Click 7: Here is why this is not just our problem. These frictions are now written into federal rules. Since January 2026, a decision is due in 72 hours for an expedited request and 7 calendar days for a standard one. That means an approval or a denial. Every denial needs a specific reason. And plans must publish their prior authorization results every year. The first report was due in March.
+Click 8: And a pend does not stop that clock. A plan can extend by up to 14 calendar days, but only if it justifies the delay as in the member's interest and tells the member in writing. So every avoidable pend is a documented delay, not a quiet pause.
+Click 9: Then in January 2027, about three months from now, four data interfaces go live. One of them, the Patient Access API, must show the member where a prior authorization stands. The member will finally have a window into the process.
+Click 10: So these are not just frictions we feel inside the process. Federal rules now set the clock, ask for the reason, and make the results public. Getting every case to a decision inside that clock matters more than ever.</a:t>
             </a:r>
             <a:endParaRPr lang="en-US" dirty="0"/>
           </a:p>
@@ -2636,11 +2640,11 @@
             </a:avLst>
           </a:prstGeom>
           <a:solidFill>
-            <a:srgbClr val="EBE2F8"/>
+            <a:srgbClr val="FFFFFF"/>
           </a:solidFill>
           <a:ln w="15875">
             <a:solidFill>
-              <a:srgbClr val="5F3AA8"/>
+              <a:srgbClr val="CBD5D1"/>
             </a:solidFill>
           </a:ln>
         </p:spPr>
@@ -2695,23 +2699,6 @@
                 <a:cs typeface="Calibri" pitchFamily="34" charset="-120"/>
               </a:rPr>
               <a:t>Felt by: the member</a:t>
-            </a:r>
-            <a:endParaRPr lang="en-US" sz="1500" dirty="0"/>
-          </a:p>
-          <a:p>
-            <a:pPr algn="l" indent="0" marL="0">
-              <a:buNone/>
-            </a:pPr>
-            <a:r>
-              <a:rPr lang="en-US" sz="1100" b="1" dirty="0">
-                <a:solidFill>
-                  <a:srgbClr val="5F3AA8"/>
-                </a:solidFill>
-                <a:latin typeface="Calibri" pitchFamily="34" charset="0"/>
-                <a:ea typeface="Calibri" pitchFamily="34" charset="-122"/>
-                <a:cs typeface="Calibri" pitchFamily="34" charset="-120"/>
-              </a:rPr>
-              <a:t>Phase 2. It needs a decision feed we can trust first.</a:t>
             </a:r>
             <a:endParaRPr lang="en-US" sz="1500" dirty="0"/>
           </a:p>
@@ -2734,23 +2721,565 @@
             </a:avLst>
           </a:prstGeom>
           <a:solidFill>
-            <a:srgbClr val="5F3AA8"/>
+            <a:srgbClr val="B8452F"/>
           </a:solidFill>
           <a:ln w="12700">
+            <a:solidFill>
+              <a:srgbClr val="B8452F"/>
+            </a:solidFill>
+          </a:ln>
+        </p:spPr>
+        <p:txBody>
+          <a:bodyPr wrap="square" lIns="0" tIns="0" rIns="0" bIns="0" rtlCol="0" anchor="ctr"/>
+          <a:lstStyle/>
+          <a:p>
+            <a:pPr algn="ctr" indent="0" marL="0">
+              <a:buNone/>
+            </a:pPr>
+            <a:r>
+              <a:rPr lang="en-US" sz="1100" b="1" dirty="0">
+                <a:solidFill>
+                  <a:srgbClr val="FFFFFF"/>
+                </a:solidFill>
+                <a:latin typeface="Calibri" pitchFamily="34" charset="0"/>
+                <a:ea typeface="Calibri" pitchFamily="34" charset="-122"/>
+                <a:cs typeface="Calibri" pitchFamily="34" charset="-120"/>
+              </a:rPr>
+              <a:t>6</a:t>
+            </a:r>
+            <a:endParaRPr lang="en-US" sz="1100" dirty="0"/>
+          </a:p>
+        </p:txBody>
+      </p:sp>
+      <p:sp>
+        <p:nvSpPr>
+          <p:cNvPr id="42" name="titleB"/>
+          <p:cNvSpPr txBox="1"/>
+          <p:nvPr/>
+        </p:nvSpPr>
+        <p:spPr>
+          <a:xfrm>
+            <a:off x="457200" y="502920"/>
+            <a:ext cx="8229600" cy="685800"/>
+          </a:xfrm>
+          <a:prstGeom prst="rect">
+            <a:avLst/>
+          </a:prstGeom>
+          <a:noFill/>
+          <a:ln/>
+        </p:spPr>
+        <p:txBody>
+          <a:bodyPr wrap="square" lIns="0" tIns="0" rIns="0" bIns="0" rtlCol="0" anchor="ctr"/>
+          <a:lstStyle/>
+          <a:p>
+            <a:pPr algn="l" indent="0" marL="0">
+              <a:buNone/>
+            </a:pPr>
+            <a:r>
+              <a:rPr lang="en-US" sz="2600" dirty="0">
+                <a:solidFill>
+                  <a:srgbClr val="16211E"/>
+                </a:solidFill>
+                <a:latin typeface="Cambria" pitchFamily="34" charset="0"/>
+                <a:ea typeface="Cambria" pitchFamily="34" charset="-122"/>
+                <a:cs typeface="Cambria" pitchFamily="34" charset="-120"/>
+              </a:rPr>
+              <a:t>Federal rules now put a clock on all of this.</a:t>
+            </a:r>
+            <a:endParaRPr lang="en-US" sz="2600" dirty="0"/>
+          </a:p>
+        </p:txBody>
+      </p:sp>
+      <p:sp>
+        <p:nvSpPr>
+          <p:cNvPr id="43" name="subB"/>
+          <p:cNvSpPr txBox="1"/>
+          <p:nvPr/>
+        </p:nvSpPr>
+        <p:spPr>
+          <a:xfrm>
+            <a:off x="6675120" y="502920"/>
+            <a:ext cx="5056632" cy="685800"/>
+          </a:xfrm>
+          <a:prstGeom prst="rect">
+            <a:avLst/>
+          </a:prstGeom>
+          <a:noFill/>
+          <a:ln/>
+        </p:spPr>
+        <p:txBody>
+          <a:bodyPr wrap="square" lIns="0" tIns="0" rIns="0" bIns="0" rtlCol="0" anchor="ctr"/>
+          <a:lstStyle/>
+          <a:p>
+            <a:pPr algn="r" indent="0" marL="0">
+              <a:buNone/>
+            </a:pPr>
+            <a:r>
+              <a:rPr lang="en-US" sz="1400" dirty="0">
+                <a:solidFill>
+                  <a:srgbClr val="5C6B66"/>
+                </a:solidFill>
+                <a:latin typeface="Calibri" pitchFamily="34" charset="0"/>
+                <a:ea typeface="Calibri" pitchFamily="34" charset="-122"/>
+                <a:cs typeface="Calibri" pitchFamily="34" charset="-120"/>
+              </a:rPr>
+              <a:t>Applies to Medicare Advantage plans, including Humana's.</a:t>
+            </a:r>
+            <a:endParaRPr lang="en-US" sz="1400" dirty="0"/>
+          </a:p>
+        </p:txBody>
+      </p:sp>
+      <p:sp>
+        <p:nvSpPr>
+          <p:cNvPr id="44" name="footerB"/>
+          <p:cNvSpPr txBox="1"/>
+          <p:nvPr/>
+        </p:nvSpPr>
+        <p:spPr>
+          <a:xfrm>
+            <a:off x="457200" y="6492240"/>
+            <a:ext cx="11274552" cy="228600"/>
+          </a:xfrm>
+          <a:prstGeom prst="rect">
+            <a:avLst/>
+          </a:prstGeom>
+          <a:noFill/>
+          <a:ln/>
+        </p:spPr>
+        <p:txBody>
+          <a:bodyPr wrap="square" lIns="0" tIns="0" rIns="0" bIns="0" rtlCol="0" anchor="t"/>
+          <a:lstStyle/>
+          <a:p>
+            <a:pPr algn="l" indent="0" marL="0">
+              <a:buNone/>
+            </a:pPr>
+            <a:r>
+              <a:rPr lang="en-US" sz="900" dirty="0">
+                <a:solidFill>
+                  <a:srgbClr val="5C6B66"/>
+                </a:solidFill>
+                <a:latin typeface="Calibri" pitchFamily="34" charset="0"/>
+                <a:ea typeface="Calibri" pitchFamily="34" charset="-122"/>
+                <a:cs typeface="Calibri" pitchFamily="34" charset="-120"/>
+              </a:rPr>
+              <a:t>Sources: CMS-0057-F final rule and fact sheet (cms.gov). 42 CFR 422.568(b).</a:t>
+            </a:r>
+            <a:endParaRPr lang="en-US" sz="900" dirty="0"/>
+          </a:p>
+        </p:txBody>
+      </p:sp>
+      <p:sp>
+        <p:nvSpPr>
+          <p:cNvPr id="45" name="Fed1"/>
+          <p:cNvSpPr/>
+          <p:nvPr/>
+        </p:nvSpPr>
+        <p:spPr>
+          <a:xfrm>
+            <a:off x="457200" y="3090672"/>
+            <a:ext cx="3657600" cy="2331720"/>
+          </a:xfrm>
+          <a:prstGeom prst="roundRect">
+            <a:avLst>
+              <a:gd name="adj" fmla="val 3137"/>
+            </a:avLst>
+          </a:prstGeom>
+          <a:solidFill>
+            <a:srgbClr val="FFFFFF"/>
+          </a:solidFill>
+          <a:ln w="19050">
+            <a:solidFill>
+              <a:srgbClr val="B8452F"/>
+            </a:solidFill>
+          </a:ln>
+        </p:spPr>
+        <p:txBody>
+          <a:bodyPr wrap="square" lIns="164592" tIns="146304" rIns="164592" bIns="91440" rtlCol="0" anchor="t"/>
+          <a:lstStyle/>
+          <a:p>
+            <a:pPr algn="l" indent="0" marL="0">
+              <a:spcAft>
+                <a:spcPts val="400"/>
+              </a:spcAft>
+              <a:buNone/>
+            </a:pPr>
+            <a:r>
+              <a:rPr lang="en-US" sz="1000" b="1" spc="200" kern="0" dirty="0">
+                <a:solidFill>
+                  <a:srgbClr val="B8452F"/>
+                </a:solidFill>
+                <a:latin typeface="Calibri" pitchFamily="34" charset="0"/>
+                <a:ea typeface="Calibri" pitchFamily="34" charset="-122"/>
+                <a:cs typeface="Calibri" pitchFamily="34" charset="-120"/>
+              </a:rPr>
+              <a:t>IN EFFECT SINCE JANUARY 2026</a:t>
+            </a:r>
+            <a:endParaRPr lang="en-US" sz="1000" dirty="0"/>
+          </a:p>
+          <a:p>
+            <a:pPr algn="l" indent="0" marL="0">
+              <a:spcAft>
+                <a:spcPts val="800"/>
+              </a:spcAft>
+              <a:buNone/>
+            </a:pPr>
+            <a:r>
+              <a:rPr lang="en-US" sz="1600" b="1" dirty="0">
+                <a:solidFill>
+                  <a:srgbClr val="16211E"/>
+                </a:solidFill>
+                <a:latin typeface="Calibri" pitchFamily="34" charset="0"/>
+                <a:ea typeface="Calibri" pitchFamily="34" charset="-122"/>
+                <a:cs typeface="Calibri" pitchFamily="34" charset="-120"/>
+              </a:rPr>
+              <a:t>Decisions have a deadline</a:t>
+            </a:r>
+            <a:endParaRPr lang="en-US" sz="1000" dirty="0"/>
+          </a:p>
+          <a:p>
+            <a:pPr algn="l" marL="177800" indent="-177800">
+              <a:spcAft>
+                <a:spcPts val="500"/>
+              </a:spcAft>
+              <a:buSzPct val="100000"/>
+              <a:buChar char="•"/>
+            </a:pPr>
+            <a:r>
+              <a:rPr lang="en-US" sz="1250" dirty="0">
+                <a:solidFill>
+                  <a:srgbClr val="16211E"/>
+                </a:solidFill>
+                <a:latin typeface="Calibri" pitchFamily="34" charset="0"/>
+                <a:ea typeface="Calibri" pitchFamily="34" charset="-122"/>
+                <a:cs typeface="Calibri" pitchFamily="34" charset="-120"/>
+              </a:rPr>
+              <a:t>72 hours for expedited requests. 7 calendar days for standard ones. An approval or a denial, not a pend.</a:t>
+            </a:r>
+            <a:endParaRPr lang="en-US" sz="1000" dirty="0"/>
+          </a:p>
+          <a:p>
+            <a:pPr algn="l" marL="177800" indent="-177800">
+              <a:spcAft>
+                <a:spcPts val="500"/>
+              </a:spcAft>
+              <a:buSzPct val="100000"/>
+              <a:buChar char="•"/>
+            </a:pPr>
+            <a:r>
+              <a:rPr lang="en-US" sz="1250" dirty="0">
+                <a:solidFill>
+                  <a:srgbClr val="16211E"/>
+                </a:solidFill>
+                <a:latin typeface="Calibri" pitchFamily="34" charset="0"/>
+                <a:ea typeface="Calibri" pitchFamily="34" charset="-122"/>
+                <a:cs typeface="Calibri" pitchFamily="34" charset="-120"/>
+              </a:rPr>
+              <a:t>A specific reason on every denial.</a:t>
+            </a:r>
+            <a:endParaRPr lang="en-US" sz="1000" dirty="0"/>
+          </a:p>
+          <a:p>
+            <a:pPr algn="l" marL="177800" indent="-177800">
+              <a:spcAft>
+                <a:spcPts val="500"/>
+              </a:spcAft>
+              <a:buSzPct val="100000"/>
+              <a:buChar char="•"/>
+            </a:pPr>
+            <a:r>
+              <a:rPr lang="en-US" sz="1250" dirty="0">
+                <a:solidFill>
+                  <a:srgbClr val="16211E"/>
+                </a:solidFill>
+                <a:latin typeface="Calibri" pitchFamily="34" charset="0"/>
+                <a:ea typeface="Calibri" pitchFamily="34" charset="-122"/>
+                <a:cs typeface="Calibri" pitchFamily="34" charset="-120"/>
+              </a:rPr>
+              <a:t>Prior authorization results published every year. The first report was due March 31, 2026.</a:t>
+            </a:r>
+            <a:endParaRPr lang="en-US" sz="1000" dirty="0"/>
+          </a:p>
+        </p:txBody>
+      </p:sp>
+      <p:sp>
+        <p:nvSpPr>
+          <p:cNvPr id="46" name="Fed2"/>
+          <p:cNvSpPr/>
+          <p:nvPr/>
+        </p:nvSpPr>
+        <p:spPr>
+          <a:xfrm>
+            <a:off x="4265676" y="3090672"/>
+            <a:ext cx="3657600" cy="2331720"/>
+          </a:xfrm>
+          <a:prstGeom prst="roundRect">
+            <a:avLst>
+              <a:gd name="adj" fmla="val 3137"/>
+            </a:avLst>
+          </a:prstGeom>
+          <a:solidFill>
+            <a:srgbClr val="FFFFFF"/>
+          </a:solidFill>
+          <a:ln w="19050">
+            <a:solidFill>
+              <a:srgbClr val="8A5A00"/>
+            </a:solidFill>
+          </a:ln>
+        </p:spPr>
+        <p:txBody>
+          <a:bodyPr wrap="square" lIns="164592" tIns="146304" rIns="164592" bIns="91440" rtlCol="0" anchor="t"/>
+          <a:lstStyle/>
+          <a:p>
+            <a:pPr algn="l" indent="0" marL="0">
+              <a:spcAft>
+                <a:spcPts val="400"/>
+              </a:spcAft>
+              <a:buNone/>
+            </a:pPr>
+            <a:r>
+              <a:rPr lang="en-US" sz="1000" b="1" spc="200" kern="0" dirty="0">
+                <a:solidFill>
+                  <a:srgbClr val="8A5A00"/>
+                </a:solidFill>
+                <a:latin typeface="Calibri" pitchFamily="34" charset="0"/>
+                <a:ea typeface="Calibri" pitchFamily="34" charset="-122"/>
+                <a:cs typeface="Calibri" pitchFamily="34" charset="-120"/>
+              </a:rPr>
+              <a:t>THE RULE ON PENDING</a:t>
+            </a:r>
+            <a:endParaRPr lang="en-US" sz="1000" dirty="0"/>
+          </a:p>
+          <a:p>
+            <a:pPr algn="l" indent="0" marL="0">
+              <a:spcAft>
+                <a:spcPts val="800"/>
+              </a:spcAft>
+              <a:buNone/>
+            </a:pPr>
+            <a:r>
+              <a:rPr lang="en-US" sz="1600" b="1" dirty="0">
+                <a:solidFill>
+                  <a:srgbClr val="16211E"/>
+                </a:solidFill>
+                <a:latin typeface="Calibri" pitchFamily="34" charset="0"/>
+                <a:ea typeface="Calibri" pitchFamily="34" charset="-122"/>
+                <a:cs typeface="Calibri" pitchFamily="34" charset="-120"/>
+              </a:rPr>
+              <a:t>A pend does not stop the clock</a:t>
+            </a:r>
+            <a:endParaRPr lang="en-US" sz="1000" dirty="0"/>
+          </a:p>
+          <a:p>
+            <a:pPr algn="l" marL="177800" indent="-177800">
+              <a:spcAft>
+                <a:spcPts val="500"/>
+              </a:spcAft>
+              <a:buSzPct val="100000"/>
+              <a:buChar char="•"/>
+            </a:pPr>
+            <a:r>
+              <a:rPr lang="en-US" sz="1250" dirty="0">
+                <a:solidFill>
+                  <a:srgbClr val="16211E"/>
+                </a:solidFill>
+                <a:latin typeface="Calibri" pitchFamily="34" charset="0"/>
+                <a:ea typeface="Calibri" pitchFamily="34" charset="-122"/>
+                <a:cs typeface="Calibri" pitchFamily="34" charset="-120"/>
+              </a:rPr>
+              <a:t>Asking the provider for more information does not pause it.</a:t>
+            </a:r>
+            <a:endParaRPr lang="en-US" sz="1000" dirty="0"/>
+          </a:p>
+          <a:p>
+            <a:pPr algn="l" marL="177800" indent="-177800">
+              <a:spcAft>
+                <a:spcPts val="500"/>
+              </a:spcAft>
+              <a:buSzPct val="100000"/>
+              <a:buChar char="•"/>
+            </a:pPr>
+            <a:r>
+              <a:rPr lang="en-US" sz="1250" dirty="0">
+                <a:solidFill>
+                  <a:srgbClr val="16211E"/>
+                </a:solidFill>
+                <a:latin typeface="Calibri" pitchFamily="34" charset="0"/>
+                <a:ea typeface="Calibri" pitchFamily="34" charset="-122"/>
+                <a:cs typeface="Calibri" pitchFamily="34" charset="-120"/>
+              </a:rPr>
+              <a:t>The plan may extend by up to 14 calendar days.</a:t>
+            </a:r>
+            <a:endParaRPr lang="en-US" sz="1000" dirty="0"/>
+          </a:p>
+          <a:p>
+            <a:pPr algn="l" marL="177800" indent="-177800">
+              <a:spcAft>
+                <a:spcPts val="500"/>
+              </a:spcAft>
+              <a:buSzPct val="100000"/>
+              <a:buChar char="•"/>
+            </a:pPr>
+            <a:r>
+              <a:rPr lang="en-US" sz="1250" dirty="0">
+                <a:solidFill>
+                  <a:srgbClr val="16211E"/>
+                </a:solidFill>
+                <a:latin typeface="Calibri" pitchFamily="34" charset="0"/>
+                <a:ea typeface="Calibri" pitchFamily="34" charset="-122"/>
+                <a:cs typeface="Calibri" pitchFamily="34" charset="-120"/>
+              </a:rPr>
+              <a:t>Only if it justifies the delay as in the member's interest, and tells the member in writing.</a:t>
+            </a:r>
+            <a:endParaRPr lang="en-US" sz="1000" dirty="0"/>
+          </a:p>
+        </p:txBody>
+      </p:sp>
+      <p:sp>
+        <p:nvSpPr>
+          <p:cNvPr id="47" name="Fed3"/>
+          <p:cNvSpPr/>
+          <p:nvPr/>
+        </p:nvSpPr>
+        <p:spPr>
+          <a:xfrm>
+            <a:off x="8074152" y="3090672"/>
+            <a:ext cx="3657600" cy="2331720"/>
+          </a:xfrm>
+          <a:prstGeom prst="roundRect">
+            <a:avLst>
+              <a:gd name="adj" fmla="val 3137"/>
+            </a:avLst>
+          </a:prstGeom>
+          <a:solidFill>
+            <a:srgbClr val="FFFFFF"/>
+          </a:solidFill>
+          <a:ln w="19050">
             <a:solidFill>
               <a:srgbClr val="5F3AA8"/>
             </a:solidFill>
           </a:ln>
         </p:spPr>
         <p:txBody>
-          <a:bodyPr wrap="square" lIns="0" tIns="0" rIns="0" bIns="0" rtlCol="0" anchor="ctr"/>
+          <a:bodyPr wrap="square" lIns="164592" tIns="146304" rIns="164592" bIns="91440" rtlCol="0" anchor="t"/>
           <a:lstStyle/>
           <a:p>
-            <a:pPr algn="ctr" indent="0" marL="0">
-              <a:buNone/>
-            </a:pPr>
-            <a:r>
-              <a:rPr lang="en-US" sz="1100" b="1" dirty="0">
+            <a:pPr algn="l" indent="0" marL="0">
+              <a:spcAft>
+                <a:spcPts val="400"/>
+              </a:spcAft>
+              <a:buNone/>
+            </a:pPr>
+            <a:r>
+              <a:rPr lang="en-US" sz="1000" b="1" spc="200" kern="0" dirty="0">
+                <a:solidFill>
+                  <a:srgbClr val="5F3AA8"/>
+                </a:solidFill>
+                <a:latin typeface="Calibri" pitchFamily="34" charset="0"/>
+                <a:ea typeface="Calibri" pitchFamily="34" charset="-122"/>
+                <a:cs typeface="Calibri" pitchFamily="34" charset="-120"/>
+              </a:rPr>
+              <a:t>COMING JANUARY 2027</a:t>
+            </a:r>
+            <a:endParaRPr lang="en-US" sz="1000" dirty="0"/>
+          </a:p>
+          <a:p>
+            <a:pPr algn="l" indent="0" marL="0">
+              <a:spcAft>
+                <a:spcPts val="800"/>
+              </a:spcAft>
+              <a:buNone/>
+            </a:pPr>
+            <a:r>
+              <a:rPr lang="en-US" sz="1600" b="1" dirty="0">
+                <a:solidFill>
+                  <a:srgbClr val="16211E"/>
+                </a:solidFill>
+                <a:latin typeface="Calibri" pitchFamily="34" charset="0"/>
+                <a:ea typeface="Calibri" pitchFamily="34" charset="-122"/>
+                <a:cs typeface="Calibri" pitchFamily="34" charset="-120"/>
+              </a:rPr>
+              <a:t>The member gets a window</a:t>
+            </a:r>
+            <a:endParaRPr lang="en-US" sz="1000" dirty="0"/>
+          </a:p>
+          <a:p>
+            <a:pPr algn="l" marL="177800" indent="-177800">
+              <a:spcAft>
+                <a:spcPts val="500"/>
+              </a:spcAft>
+              <a:buSzPct val="100000"/>
+              <a:buChar char="•"/>
+            </a:pPr>
+            <a:r>
+              <a:rPr lang="en-US" sz="1250" dirty="0">
+                <a:solidFill>
+                  <a:srgbClr val="16211E"/>
+                </a:solidFill>
+                <a:latin typeface="Calibri" pitchFamily="34" charset="0"/>
+                <a:ea typeface="Calibri" pitchFamily="34" charset="-122"/>
+                <a:cs typeface="Calibri" pitchFamily="34" charset="-120"/>
+              </a:rPr>
+              <a:t>Four data interfaces (FHIR APIs) go live.</a:t>
+            </a:r>
+            <a:endParaRPr lang="en-US" sz="1000" dirty="0"/>
+          </a:p>
+          <a:p>
+            <a:pPr algn="l" marL="177800" indent="-177800">
+              <a:spcAft>
+                <a:spcPts val="500"/>
+              </a:spcAft>
+              <a:buSzPct val="100000"/>
+              <a:buChar char="•"/>
+            </a:pPr>
+            <a:r>
+              <a:rPr lang="en-US" sz="1250" dirty="0">
+                <a:solidFill>
+                  <a:srgbClr val="16211E"/>
+                </a:solidFill>
+                <a:latin typeface="Calibri" pitchFamily="34" charset="0"/>
+                <a:ea typeface="Calibri" pitchFamily="34" charset="-122"/>
+                <a:cs typeface="Calibri" pitchFamily="34" charset="-120"/>
+              </a:rPr>
+              <a:t>One of them, the Patient Access API, must show the member where a prior authorization stands.</a:t>
+            </a:r>
+            <a:endParaRPr lang="en-US" sz="1000" dirty="0"/>
+          </a:p>
+        </p:txBody>
+      </p:sp>
+      <p:sp>
+        <p:nvSpPr>
+          <p:cNvPr id="48" name="Banner"/>
+          <p:cNvSpPr/>
+          <p:nvPr/>
+        </p:nvSpPr>
+        <p:spPr>
+          <a:xfrm>
+            <a:off x="457200" y="5577840"/>
+            <a:ext cx="11274552" cy="731520"/>
+          </a:xfrm>
+          <a:prstGeom prst="roundRect">
+            <a:avLst>
+              <a:gd name="adj" fmla="val 10000"/>
+            </a:avLst>
+          </a:prstGeom>
+          <a:solidFill>
+            <a:srgbClr val="1F6F5C"/>
+          </a:solidFill>
+          <a:ln w="12700">
+            <a:solidFill>
+              <a:srgbClr val="1F6F5C"/>
+            </a:solidFill>
+          </a:ln>
+        </p:spPr>
+        <p:txBody>
+          <a:bodyPr wrap="square" lIns="228600" tIns="54864" rIns="228600" bIns="54864" rtlCol="0" anchor="ctr"/>
+          <a:lstStyle/>
+          <a:p>
+            <a:pPr algn="l" indent="0" marL="0">
+              <a:buNone/>
+            </a:pPr>
+            <a:r>
+              <a:rPr lang="en-US" sz="1400" b="1" dirty="0">
                 <a:solidFill>
                   <a:srgbClr val="FFFFFF"/>
                 </a:solidFill>
@@ -2758,9 +3287,9 @@
                 <a:ea typeface="Calibri" pitchFamily="34" charset="-122"/>
                 <a:cs typeface="Calibri" pitchFamily="34" charset="-120"/>
               </a:rPr>
-              <a:t>6</a:t>
-            </a:r>
-            <a:endParaRPr lang="en-US" sz="1100" dirty="0"/>
+              <a:t>These are not just frictions we feel. Federal rules now set the clock, ask for the reason, and make the results public. Getting every case to a decision inside that clock matters more than ever.</a:t>
+            </a:r>
+            <a:endParaRPr lang="en-US" sz="1400" dirty="0"/>
           </a:p>
         </p:txBody>
       </p:sp>
@@ -3503,6 +4032,1058 @@
                                         <p:cTn id="67" dur="500"/>
                                         <p:tgtEl>
                                           <p:spTgt spid="29"/>
+                                        </p:tgtEl>
+                                      </p:cBhvr>
+                                    </p:animEffect>
+                                  </p:childTnLst>
+                                </p:cTn>
+                              </p:par>
+                            </p:childTnLst>
+                          </p:cTn>
+                        </p:par>
+                      </p:childTnLst>
+                    </p:cTn>
+                  </p:par>
+                  <p:par>
+                    <p:cTn id="69" fill="hold">
+                      <p:stCondLst>
+                        <p:cond delay="indefinite"/>
+                      </p:stCondLst>
+                      <p:childTnLst>
+                        <p:par>
+                          <p:cTn id="70" fill="hold">
+                            <p:stCondLst>
+                              <p:cond delay="0"/>
+                            </p:stCondLst>
+                            <p:childTnLst>
+                              <p:par>
+                                <p:cTn id="73" presetID="10" presetClass="exit" presetSubtype="0" fill="hold" grpId="0" nodeType="clickEffect">
+                                  <p:stCondLst>
+                                    <p:cond delay="0"/>
+                                  </p:stCondLst>
+                                  <p:childTnLst>
+                                    <p:animEffect transition="out" filter="fade">
+                                      <p:cBhvr>
+                                        <p:cTn id="71" dur="300"/>
+                                        <p:tgtEl>
+                                          <p:spTgt spid="30"/>
+                                        </p:tgtEl>
+                                      </p:cBhvr>
+                                    </p:animEffect>
+                                    <p:set>
+                                      <p:cBhvr>
+                                        <p:cTn id="72" dur="1" fill="hold">
+                                          <p:stCondLst>
+                                            <p:cond delay="299"/>
+                                          </p:stCondLst>
+                                        </p:cTn>
+                                        <p:tgtEl>
+                                          <p:spTgt spid="30"/>
+                                        </p:tgtEl>
+                                        <p:attrNameLst>
+                                          <p:attrName>style.visibility</p:attrName>
+                                        </p:attrNameLst>
+                                      </p:cBhvr>
+                                      <p:to>
+                                        <p:strVal val="hidden"/>
+                                      </p:to>
+                                    </p:set>
+                                  </p:childTnLst>
+                                </p:cTn>
+                              </p:par>
+                              <p:par>
+                                <p:cTn id="76" presetID="10" presetClass="exit" presetSubtype="0" fill="hold" grpId="0" nodeType="withEffect">
+                                  <p:stCondLst>
+                                    <p:cond delay="0"/>
+                                  </p:stCondLst>
+                                  <p:childTnLst>
+                                    <p:animEffect transition="out" filter="fade">
+                                      <p:cBhvr>
+                                        <p:cTn id="74" dur="300"/>
+                                        <p:tgtEl>
+                                          <p:spTgt spid="31"/>
+                                        </p:tgtEl>
+                                      </p:cBhvr>
+                                    </p:animEffect>
+                                    <p:set>
+                                      <p:cBhvr>
+                                        <p:cTn id="75" dur="1" fill="hold">
+                                          <p:stCondLst>
+                                            <p:cond delay="299"/>
+                                          </p:stCondLst>
+                                        </p:cTn>
+                                        <p:tgtEl>
+                                          <p:spTgt spid="31"/>
+                                        </p:tgtEl>
+                                        <p:attrNameLst>
+                                          <p:attrName>style.visibility</p:attrName>
+                                        </p:attrNameLst>
+                                      </p:cBhvr>
+                                      <p:to>
+                                        <p:strVal val="hidden"/>
+                                      </p:to>
+                                    </p:set>
+                                  </p:childTnLst>
+                                </p:cTn>
+                              </p:par>
+                              <p:par>
+                                <p:cTn id="79" presetID="10" presetClass="exit" presetSubtype="0" fill="hold" grpId="0" nodeType="withEffect">
+                                  <p:stCondLst>
+                                    <p:cond delay="0"/>
+                                  </p:stCondLst>
+                                  <p:childTnLst>
+                                    <p:animEffect transition="out" filter="fade">
+                                      <p:cBhvr>
+                                        <p:cTn id="77" dur="300"/>
+                                        <p:tgtEl>
+                                          <p:spTgt spid="24"/>
+                                        </p:tgtEl>
+                                      </p:cBhvr>
+                                    </p:animEffect>
+                                    <p:set>
+                                      <p:cBhvr>
+                                        <p:cTn id="78" dur="1" fill="hold">
+                                          <p:stCondLst>
+                                            <p:cond delay="299"/>
+                                          </p:stCondLst>
+                                        </p:cTn>
+                                        <p:tgtEl>
+                                          <p:spTgt spid="24"/>
+                                        </p:tgtEl>
+                                        <p:attrNameLst>
+                                          <p:attrName>style.visibility</p:attrName>
+                                        </p:attrNameLst>
+                                      </p:cBhvr>
+                                      <p:to>
+                                        <p:strVal val="hidden"/>
+                                      </p:to>
+                                    </p:set>
+                                  </p:childTnLst>
+                                </p:cTn>
+                              </p:par>
+                              <p:par>
+                                <p:cTn id="82" presetID="10" presetClass="exit" presetSubtype="0" fill="hold" grpId="0" nodeType="withEffect">
+                                  <p:stCondLst>
+                                    <p:cond delay="0"/>
+                                  </p:stCondLst>
+                                  <p:childTnLst>
+                                    <p:animEffect transition="out" filter="fade">
+                                      <p:cBhvr>
+                                        <p:cTn id="80" dur="300"/>
+                                        <p:tgtEl>
+                                          <p:spTgt spid="32"/>
+                                        </p:tgtEl>
+                                      </p:cBhvr>
+                                    </p:animEffect>
+                                    <p:set>
+                                      <p:cBhvr>
+                                        <p:cTn id="81" dur="1" fill="hold">
+                                          <p:stCondLst>
+                                            <p:cond delay="299"/>
+                                          </p:stCondLst>
+                                        </p:cTn>
+                                        <p:tgtEl>
+                                          <p:spTgt spid="32"/>
+                                        </p:tgtEl>
+                                        <p:attrNameLst>
+                                          <p:attrName>style.visibility</p:attrName>
+                                        </p:attrNameLst>
+                                      </p:cBhvr>
+                                      <p:to>
+                                        <p:strVal val="hidden"/>
+                                      </p:to>
+                                    </p:set>
+                                  </p:childTnLst>
+                                </p:cTn>
+                              </p:par>
+                              <p:par>
+                                <p:cTn id="85" presetID="10" presetClass="exit" presetSubtype="0" fill="hold" grpId="0" nodeType="withEffect">
+                                  <p:stCondLst>
+                                    <p:cond delay="0"/>
+                                  </p:stCondLst>
+                                  <p:childTnLst>
+                                    <p:animEffect transition="out" filter="fade">
+                                      <p:cBhvr>
+                                        <p:cTn id="83" dur="300"/>
+                                        <p:tgtEl>
+                                          <p:spTgt spid="33"/>
+                                        </p:tgtEl>
+                                      </p:cBhvr>
+                                    </p:animEffect>
+                                    <p:set>
+                                      <p:cBhvr>
+                                        <p:cTn id="84" dur="1" fill="hold">
+                                          <p:stCondLst>
+                                            <p:cond delay="299"/>
+                                          </p:stCondLst>
+                                        </p:cTn>
+                                        <p:tgtEl>
+                                          <p:spTgt spid="33"/>
+                                        </p:tgtEl>
+                                        <p:attrNameLst>
+                                          <p:attrName>style.visibility</p:attrName>
+                                        </p:attrNameLst>
+                                      </p:cBhvr>
+                                      <p:to>
+                                        <p:strVal val="hidden"/>
+                                      </p:to>
+                                    </p:set>
+                                  </p:childTnLst>
+                                </p:cTn>
+                              </p:par>
+                              <p:par>
+                                <p:cTn id="88" presetID="10" presetClass="exit" presetSubtype="0" fill="hold" grpId="0" nodeType="withEffect">
+                                  <p:stCondLst>
+                                    <p:cond delay="0"/>
+                                  </p:stCondLst>
+                                  <p:childTnLst>
+                                    <p:animEffect transition="out" filter="fade">
+                                      <p:cBhvr>
+                                        <p:cTn id="86" dur="300"/>
+                                        <p:tgtEl>
+                                          <p:spTgt spid="26"/>
+                                        </p:tgtEl>
+                                      </p:cBhvr>
+                                    </p:animEffect>
+                                    <p:set>
+                                      <p:cBhvr>
+                                        <p:cTn id="87" dur="1" fill="hold">
+                                          <p:stCondLst>
+                                            <p:cond delay="299"/>
+                                          </p:stCondLst>
+                                        </p:cTn>
+                                        <p:tgtEl>
+                                          <p:spTgt spid="26"/>
+                                        </p:tgtEl>
+                                        <p:attrNameLst>
+                                          <p:attrName>style.visibility</p:attrName>
+                                        </p:attrNameLst>
+                                      </p:cBhvr>
+                                      <p:to>
+                                        <p:strVal val="hidden"/>
+                                      </p:to>
+                                    </p:set>
+                                  </p:childTnLst>
+                                </p:cTn>
+                              </p:par>
+                              <p:par>
+                                <p:cTn id="91" presetID="10" presetClass="exit" presetSubtype="0" fill="hold" grpId="0" nodeType="withEffect">
+                                  <p:stCondLst>
+                                    <p:cond delay="0"/>
+                                  </p:stCondLst>
+                                  <p:childTnLst>
+                                    <p:animEffect transition="out" filter="fade">
+                                      <p:cBhvr>
+                                        <p:cTn id="89" dur="300"/>
+                                        <p:tgtEl>
+                                          <p:spTgt spid="34"/>
+                                        </p:tgtEl>
+                                      </p:cBhvr>
+                                    </p:animEffect>
+                                    <p:set>
+                                      <p:cBhvr>
+                                        <p:cTn id="90" dur="1" fill="hold">
+                                          <p:stCondLst>
+                                            <p:cond delay="299"/>
+                                          </p:stCondLst>
+                                        </p:cTn>
+                                        <p:tgtEl>
+                                          <p:spTgt spid="34"/>
+                                        </p:tgtEl>
+                                        <p:attrNameLst>
+                                          <p:attrName>style.visibility</p:attrName>
+                                        </p:attrNameLst>
+                                      </p:cBhvr>
+                                      <p:to>
+                                        <p:strVal val="hidden"/>
+                                      </p:to>
+                                    </p:set>
+                                  </p:childTnLst>
+                                </p:cTn>
+                              </p:par>
+                              <p:par>
+                                <p:cTn id="94" presetID="10" presetClass="exit" presetSubtype="0" fill="hold" grpId="0" nodeType="withEffect">
+                                  <p:stCondLst>
+                                    <p:cond delay="0"/>
+                                  </p:stCondLst>
+                                  <p:childTnLst>
+                                    <p:animEffect transition="out" filter="fade">
+                                      <p:cBhvr>
+                                        <p:cTn id="92" dur="300"/>
+                                        <p:tgtEl>
+                                          <p:spTgt spid="35"/>
+                                        </p:tgtEl>
+                                      </p:cBhvr>
+                                    </p:animEffect>
+                                    <p:set>
+                                      <p:cBhvr>
+                                        <p:cTn id="93" dur="1" fill="hold">
+                                          <p:stCondLst>
+                                            <p:cond delay="299"/>
+                                          </p:stCondLst>
+                                        </p:cTn>
+                                        <p:tgtEl>
+                                          <p:spTgt spid="35"/>
+                                        </p:tgtEl>
+                                        <p:attrNameLst>
+                                          <p:attrName>style.visibility</p:attrName>
+                                        </p:attrNameLst>
+                                      </p:cBhvr>
+                                      <p:to>
+                                        <p:strVal val="hidden"/>
+                                      </p:to>
+                                    </p:set>
+                                  </p:childTnLst>
+                                </p:cTn>
+                              </p:par>
+                              <p:par>
+                                <p:cTn id="97" presetID="10" presetClass="exit" presetSubtype="0" fill="hold" grpId="0" nodeType="withEffect">
+                                  <p:stCondLst>
+                                    <p:cond delay="0"/>
+                                  </p:stCondLst>
+                                  <p:childTnLst>
+                                    <p:animEffect transition="out" filter="fade">
+                                      <p:cBhvr>
+                                        <p:cTn id="95" dur="300"/>
+                                        <p:tgtEl>
+                                          <p:spTgt spid="25"/>
+                                        </p:tgtEl>
+                                      </p:cBhvr>
+                                    </p:animEffect>
+                                    <p:set>
+                                      <p:cBhvr>
+                                        <p:cTn id="96" dur="1" fill="hold">
+                                          <p:stCondLst>
+                                            <p:cond delay="299"/>
+                                          </p:stCondLst>
+                                        </p:cTn>
+                                        <p:tgtEl>
+                                          <p:spTgt spid="25"/>
+                                        </p:tgtEl>
+                                        <p:attrNameLst>
+                                          <p:attrName>style.visibility</p:attrName>
+                                        </p:attrNameLst>
+                                      </p:cBhvr>
+                                      <p:to>
+                                        <p:strVal val="hidden"/>
+                                      </p:to>
+                                    </p:set>
+                                  </p:childTnLst>
+                                </p:cTn>
+                              </p:par>
+                              <p:par>
+                                <p:cTn id="100" presetID="10" presetClass="exit" presetSubtype="0" fill="hold" grpId="0" nodeType="withEffect">
+                                  <p:stCondLst>
+                                    <p:cond delay="0"/>
+                                  </p:stCondLst>
+                                  <p:childTnLst>
+                                    <p:animEffect transition="out" filter="fade">
+                                      <p:cBhvr>
+                                        <p:cTn id="98" dur="300"/>
+                                        <p:tgtEl>
+                                          <p:spTgt spid="36"/>
+                                        </p:tgtEl>
+                                      </p:cBhvr>
+                                    </p:animEffect>
+                                    <p:set>
+                                      <p:cBhvr>
+                                        <p:cTn id="99" dur="1" fill="hold">
+                                          <p:stCondLst>
+                                            <p:cond delay="299"/>
+                                          </p:stCondLst>
+                                        </p:cTn>
+                                        <p:tgtEl>
+                                          <p:spTgt spid="36"/>
+                                        </p:tgtEl>
+                                        <p:attrNameLst>
+                                          <p:attrName>style.visibility</p:attrName>
+                                        </p:attrNameLst>
+                                      </p:cBhvr>
+                                      <p:to>
+                                        <p:strVal val="hidden"/>
+                                      </p:to>
+                                    </p:set>
+                                  </p:childTnLst>
+                                </p:cTn>
+                              </p:par>
+                              <p:par>
+                                <p:cTn id="103" presetID="10" presetClass="exit" presetSubtype="0" fill="hold" grpId="0" nodeType="withEffect">
+                                  <p:stCondLst>
+                                    <p:cond delay="0"/>
+                                  </p:stCondLst>
+                                  <p:childTnLst>
+                                    <p:animEffect transition="out" filter="fade">
+                                      <p:cBhvr>
+                                        <p:cTn id="101" dur="300"/>
+                                        <p:tgtEl>
+                                          <p:spTgt spid="37"/>
+                                        </p:tgtEl>
+                                      </p:cBhvr>
+                                    </p:animEffect>
+                                    <p:set>
+                                      <p:cBhvr>
+                                        <p:cTn id="102" dur="1" fill="hold">
+                                          <p:stCondLst>
+                                            <p:cond delay="299"/>
+                                          </p:stCondLst>
+                                        </p:cTn>
+                                        <p:tgtEl>
+                                          <p:spTgt spid="37"/>
+                                        </p:tgtEl>
+                                        <p:attrNameLst>
+                                          <p:attrName>style.visibility</p:attrName>
+                                        </p:attrNameLst>
+                                      </p:cBhvr>
+                                      <p:to>
+                                        <p:strVal val="hidden"/>
+                                      </p:to>
+                                    </p:set>
+                                  </p:childTnLst>
+                                </p:cTn>
+                              </p:par>
+                              <p:par>
+                                <p:cTn id="106" presetID="10" presetClass="exit" presetSubtype="0" fill="hold" grpId="0" nodeType="withEffect">
+                                  <p:stCondLst>
+                                    <p:cond delay="0"/>
+                                  </p:stCondLst>
+                                  <p:childTnLst>
+                                    <p:animEffect transition="out" filter="fade">
+                                      <p:cBhvr>
+                                        <p:cTn id="104" dur="300"/>
+                                        <p:tgtEl>
+                                          <p:spTgt spid="27"/>
+                                        </p:tgtEl>
+                                      </p:cBhvr>
+                                    </p:animEffect>
+                                    <p:set>
+                                      <p:cBhvr>
+                                        <p:cTn id="105" dur="1" fill="hold">
+                                          <p:stCondLst>
+                                            <p:cond delay="299"/>
+                                          </p:stCondLst>
+                                        </p:cTn>
+                                        <p:tgtEl>
+                                          <p:spTgt spid="27"/>
+                                        </p:tgtEl>
+                                        <p:attrNameLst>
+                                          <p:attrName>style.visibility</p:attrName>
+                                        </p:attrNameLst>
+                                      </p:cBhvr>
+                                      <p:to>
+                                        <p:strVal val="hidden"/>
+                                      </p:to>
+                                    </p:set>
+                                  </p:childTnLst>
+                                </p:cTn>
+                              </p:par>
+                              <p:par>
+                                <p:cTn id="109" presetID="10" presetClass="exit" presetSubtype="0" fill="hold" grpId="0" nodeType="withEffect">
+                                  <p:stCondLst>
+                                    <p:cond delay="0"/>
+                                  </p:stCondLst>
+                                  <p:childTnLst>
+                                    <p:animEffect transition="out" filter="fade">
+                                      <p:cBhvr>
+                                        <p:cTn id="107" dur="300"/>
+                                        <p:tgtEl>
+                                          <p:spTgt spid="38"/>
+                                        </p:tgtEl>
+                                      </p:cBhvr>
+                                    </p:animEffect>
+                                    <p:set>
+                                      <p:cBhvr>
+                                        <p:cTn id="108" dur="1" fill="hold">
+                                          <p:stCondLst>
+                                            <p:cond delay="299"/>
+                                          </p:stCondLst>
+                                        </p:cTn>
+                                        <p:tgtEl>
+                                          <p:spTgt spid="38"/>
+                                        </p:tgtEl>
+                                        <p:attrNameLst>
+                                          <p:attrName>style.visibility</p:attrName>
+                                        </p:attrNameLst>
+                                      </p:cBhvr>
+                                      <p:to>
+                                        <p:strVal val="hidden"/>
+                                      </p:to>
+                                    </p:set>
+                                  </p:childTnLst>
+                                </p:cTn>
+                              </p:par>
+                              <p:par>
+                                <p:cTn id="112" presetID="10" presetClass="exit" presetSubtype="0" fill="hold" grpId="0" nodeType="withEffect">
+                                  <p:stCondLst>
+                                    <p:cond delay="0"/>
+                                  </p:stCondLst>
+                                  <p:childTnLst>
+                                    <p:animEffect transition="out" filter="fade">
+                                      <p:cBhvr>
+                                        <p:cTn id="110" dur="300"/>
+                                        <p:tgtEl>
+                                          <p:spTgt spid="39"/>
+                                        </p:tgtEl>
+                                      </p:cBhvr>
+                                    </p:animEffect>
+                                    <p:set>
+                                      <p:cBhvr>
+                                        <p:cTn id="111" dur="1" fill="hold">
+                                          <p:stCondLst>
+                                            <p:cond delay="299"/>
+                                          </p:stCondLst>
+                                        </p:cTn>
+                                        <p:tgtEl>
+                                          <p:spTgt spid="39"/>
+                                        </p:tgtEl>
+                                        <p:attrNameLst>
+                                          <p:attrName>style.visibility</p:attrName>
+                                        </p:attrNameLst>
+                                      </p:cBhvr>
+                                      <p:to>
+                                        <p:strVal val="hidden"/>
+                                      </p:to>
+                                    </p:set>
+                                  </p:childTnLst>
+                                </p:cTn>
+                              </p:par>
+                              <p:par>
+                                <p:cTn id="115" presetID="10" presetClass="exit" presetSubtype="0" fill="hold" grpId="0" nodeType="withEffect">
+                                  <p:stCondLst>
+                                    <p:cond delay="0"/>
+                                  </p:stCondLst>
+                                  <p:childTnLst>
+                                    <p:animEffect transition="out" filter="fade">
+                                      <p:cBhvr>
+                                        <p:cTn id="113" dur="300"/>
+                                        <p:tgtEl>
+                                          <p:spTgt spid="28"/>
+                                        </p:tgtEl>
+                                      </p:cBhvr>
+                                    </p:animEffect>
+                                    <p:set>
+                                      <p:cBhvr>
+                                        <p:cTn id="114" dur="1" fill="hold">
+                                          <p:stCondLst>
+                                            <p:cond delay="299"/>
+                                          </p:stCondLst>
+                                        </p:cTn>
+                                        <p:tgtEl>
+                                          <p:spTgt spid="28"/>
+                                        </p:tgtEl>
+                                        <p:attrNameLst>
+                                          <p:attrName>style.visibility</p:attrName>
+                                        </p:attrNameLst>
+                                      </p:cBhvr>
+                                      <p:to>
+                                        <p:strVal val="hidden"/>
+                                      </p:to>
+                                    </p:set>
+                                  </p:childTnLst>
+                                </p:cTn>
+                              </p:par>
+                              <p:par>
+                                <p:cTn id="118" presetID="10" presetClass="exit" presetSubtype="0" fill="hold" grpId="0" nodeType="withEffect">
+                                  <p:stCondLst>
+                                    <p:cond delay="0"/>
+                                  </p:stCondLst>
+                                  <p:childTnLst>
+                                    <p:animEffect transition="out" filter="fade">
+                                      <p:cBhvr>
+                                        <p:cTn id="116" dur="300"/>
+                                        <p:tgtEl>
+                                          <p:spTgt spid="40"/>
+                                        </p:tgtEl>
+                                      </p:cBhvr>
+                                    </p:animEffect>
+                                    <p:set>
+                                      <p:cBhvr>
+                                        <p:cTn id="117" dur="1" fill="hold">
+                                          <p:stCondLst>
+                                            <p:cond delay="299"/>
+                                          </p:stCondLst>
+                                        </p:cTn>
+                                        <p:tgtEl>
+                                          <p:spTgt spid="40"/>
+                                        </p:tgtEl>
+                                        <p:attrNameLst>
+                                          <p:attrName>style.visibility</p:attrName>
+                                        </p:attrNameLst>
+                                      </p:cBhvr>
+                                      <p:to>
+                                        <p:strVal val="hidden"/>
+                                      </p:to>
+                                    </p:set>
+                                  </p:childTnLst>
+                                </p:cTn>
+                              </p:par>
+                              <p:par>
+                                <p:cTn id="121" presetID="10" presetClass="exit" presetSubtype="0" fill="hold" grpId="0" nodeType="withEffect">
+                                  <p:stCondLst>
+                                    <p:cond delay="0"/>
+                                  </p:stCondLst>
+                                  <p:childTnLst>
+                                    <p:animEffect transition="out" filter="fade">
+                                      <p:cBhvr>
+                                        <p:cTn id="119" dur="300"/>
+                                        <p:tgtEl>
+                                          <p:spTgt spid="41"/>
+                                        </p:tgtEl>
+                                      </p:cBhvr>
+                                    </p:animEffect>
+                                    <p:set>
+                                      <p:cBhvr>
+                                        <p:cTn id="120" dur="1" fill="hold">
+                                          <p:stCondLst>
+                                            <p:cond delay="299"/>
+                                          </p:stCondLst>
+                                        </p:cTn>
+                                        <p:tgtEl>
+                                          <p:spTgt spid="41"/>
+                                        </p:tgtEl>
+                                        <p:attrNameLst>
+                                          <p:attrName>style.visibility</p:attrName>
+                                        </p:attrNameLst>
+                                      </p:cBhvr>
+                                      <p:to>
+                                        <p:strVal val="hidden"/>
+                                      </p:to>
+                                    </p:set>
+                                  </p:childTnLst>
+                                </p:cTn>
+                              </p:par>
+                              <p:par>
+                                <p:cTn id="124" presetID="10" presetClass="exit" presetSubtype="0" fill="hold" grpId="0" nodeType="withEffect">
+                                  <p:stCondLst>
+                                    <p:cond delay="0"/>
+                                  </p:stCondLst>
+                                  <p:childTnLst>
+                                    <p:animEffect transition="out" filter="fade">
+                                      <p:cBhvr>
+                                        <p:cTn id="122" dur="300"/>
+                                        <p:tgtEl>
+                                          <p:spTgt spid="29"/>
+                                        </p:tgtEl>
+                                      </p:cBhvr>
+                                    </p:animEffect>
+                                    <p:set>
+                                      <p:cBhvr>
+                                        <p:cTn id="123" dur="1" fill="hold">
+                                          <p:stCondLst>
+                                            <p:cond delay="299"/>
+                                          </p:stCondLst>
+                                        </p:cTn>
+                                        <p:tgtEl>
+                                          <p:spTgt spid="29"/>
+                                        </p:tgtEl>
+                                        <p:attrNameLst>
+                                          <p:attrName>style.visibility</p:attrName>
+                                        </p:attrNameLst>
+                                      </p:cBhvr>
+                                      <p:to>
+                                        <p:strVal val="hidden"/>
+                                      </p:to>
+                                    </p:set>
+                                  </p:childTnLst>
+                                </p:cTn>
+                              </p:par>
+                              <p:par>
+                                <p:cTn id="127" presetID="10" presetClass="exit" presetSubtype="0" fill="hold" grpId="0" nodeType="withEffect">
+                                  <p:stCondLst>
+                                    <p:cond delay="0"/>
+                                  </p:stCondLst>
+                                  <p:childTnLst>
+                                    <p:animEffect transition="out" filter="fade">
+                                      <p:cBhvr>
+                                        <p:cTn id="125" dur="300"/>
+                                        <p:tgtEl>
+                                          <p:spTgt spid="3"/>
+                                        </p:tgtEl>
+                                      </p:cBhvr>
+                                    </p:animEffect>
+                                    <p:set>
+                                      <p:cBhvr>
+                                        <p:cTn id="126" dur="1" fill="hold">
+                                          <p:stCondLst>
+                                            <p:cond delay="299"/>
+                                          </p:stCondLst>
+                                        </p:cTn>
+                                        <p:tgtEl>
+                                          <p:spTgt spid="3"/>
+                                        </p:tgtEl>
+                                        <p:attrNameLst>
+                                          <p:attrName>style.visibility</p:attrName>
+                                        </p:attrNameLst>
+                                      </p:cBhvr>
+                                      <p:to>
+                                        <p:strVal val="hidden"/>
+                                      </p:to>
+                                    </p:set>
+                                  </p:childTnLst>
+                                </p:cTn>
+                              </p:par>
+                              <p:par>
+                                <p:cTn id="130" presetID="10" presetClass="exit" presetSubtype="0" fill="hold" grpId="0" nodeType="withEffect">
+                                  <p:stCondLst>
+                                    <p:cond delay="0"/>
+                                  </p:stCondLst>
+                                  <p:childTnLst>
+                                    <p:animEffect transition="out" filter="fade">
+                                      <p:cBhvr>
+                                        <p:cTn id="128" dur="300"/>
+                                        <p:tgtEl>
+                                          <p:spTgt spid="4"/>
+                                        </p:tgtEl>
+                                      </p:cBhvr>
+                                    </p:animEffect>
+                                    <p:set>
+                                      <p:cBhvr>
+                                        <p:cTn id="129" dur="1" fill="hold">
+                                          <p:stCondLst>
+                                            <p:cond delay="299"/>
+                                          </p:stCondLst>
+                                        </p:cTn>
+                                        <p:tgtEl>
+                                          <p:spTgt spid="4"/>
+                                        </p:tgtEl>
+                                        <p:attrNameLst>
+                                          <p:attrName>style.visibility</p:attrName>
+                                        </p:attrNameLst>
+                                      </p:cBhvr>
+                                      <p:to>
+                                        <p:strVal val="hidden"/>
+                                      </p:to>
+                                    </p:set>
+                                  </p:childTnLst>
+                                </p:cTn>
+                              </p:par>
+                              <p:par>
+                                <p:cTn id="133" presetID="10" presetClass="exit" presetSubtype="0" fill="hold" grpId="0" nodeType="withEffect">
+                                  <p:stCondLst>
+                                    <p:cond delay="0"/>
+                                  </p:stCondLst>
+                                  <p:childTnLst>
+                                    <p:animEffect transition="out" filter="fade">
+                                      <p:cBhvr>
+                                        <p:cTn id="131" dur="300"/>
+                                        <p:tgtEl>
+                                          <p:spTgt spid="5"/>
+                                        </p:tgtEl>
+                                      </p:cBhvr>
+                                    </p:animEffect>
+                                    <p:set>
+                                      <p:cBhvr>
+                                        <p:cTn id="132" dur="1" fill="hold">
+                                          <p:stCondLst>
+                                            <p:cond delay="299"/>
+                                          </p:stCondLst>
+                                        </p:cTn>
+                                        <p:tgtEl>
+                                          <p:spTgt spid="5"/>
+                                        </p:tgtEl>
+                                        <p:attrNameLst>
+                                          <p:attrName>style.visibility</p:attrName>
+                                        </p:attrNameLst>
+                                      </p:cBhvr>
+                                      <p:to>
+                                        <p:strVal val="hidden"/>
+                                      </p:to>
+                                    </p:set>
+                                  </p:childTnLst>
+                                </p:cTn>
+                              </p:par>
+                              <p:par>
+                                <p:cTn id="136" presetID="10" presetClass="entr" presetSubtype="0" fill="hold" grpId="0" nodeType="withEffect">
+                                  <p:stCondLst>
+                                    <p:cond delay="400"/>
+                                  </p:stCondLst>
+                                  <p:childTnLst>
+                                    <p:set>
+                                      <p:cBhvr>
+                                        <p:cTn id="134" dur="1" fill="hold">
+                                          <p:stCondLst>
+                                            <p:cond delay="0"/>
+                                          </p:stCondLst>
+                                        </p:cTn>
+                                        <p:tgtEl>
+                                          <p:spTgt spid="42"/>
+                                        </p:tgtEl>
+                                        <p:attrNameLst>
+                                          <p:attrName>style.visibility</p:attrName>
+                                        </p:attrNameLst>
+                                      </p:cBhvr>
+                                      <p:to>
+                                        <p:strVal val="visible"/>
+                                      </p:to>
+                                    </p:set>
+                                    <p:animEffect transition="in" filter="fade">
+                                      <p:cBhvr>
+                                        <p:cTn id="135" dur="500"/>
+                                        <p:tgtEl>
+                                          <p:spTgt spid="42"/>
+                                        </p:tgtEl>
+                                      </p:cBhvr>
+                                    </p:animEffect>
+                                  </p:childTnLst>
+                                </p:cTn>
+                              </p:par>
+                              <p:par>
+                                <p:cTn id="139" presetID="10" presetClass="entr" presetSubtype="0" fill="hold" grpId="0" nodeType="withEffect">
+                                  <p:stCondLst>
+                                    <p:cond delay="400"/>
+                                  </p:stCondLst>
+                                  <p:childTnLst>
+                                    <p:set>
+                                      <p:cBhvr>
+                                        <p:cTn id="137" dur="1" fill="hold">
+                                          <p:stCondLst>
+                                            <p:cond delay="0"/>
+                                          </p:stCondLst>
+                                        </p:cTn>
+                                        <p:tgtEl>
+                                          <p:spTgt spid="43"/>
+                                        </p:tgtEl>
+                                        <p:attrNameLst>
+                                          <p:attrName>style.visibility</p:attrName>
+                                        </p:attrNameLst>
+                                      </p:cBhvr>
+                                      <p:to>
+                                        <p:strVal val="visible"/>
+                                      </p:to>
+                                    </p:set>
+                                    <p:animEffect transition="in" filter="fade">
+                                      <p:cBhvr>
+                                        <p:cTn id="138" dur="500"/>
+                                        <p:tgtEl>
+                                          <p:spTgt spid="43"/>
+                                        </p:tgtEl>
+                                      </p:cBhvr>
+                                    </p:animEffect>
+                                  </p:childTnLst>
+                                </p:cTn>
+                              </p:par>
+                              <p:par>
+                                <p:cTn id="142" presetID="10" presetClass="entr" presetSubtype="0" fill="hold" grpId="0" nodeType="withEffect">
+                                  <p:stCondLst>
+                                    <p:cond delay="400"/>
+                                  </p:stCondLst>
+                                  <p:childTnLst>
+                                    <p:set>
+                                      <p:cBhvr>
+                                        <p:cTn id="140" dur="1" fill="hold">
+                                          <p:stCondLst>
+                                            <p:cond delay="0"/>
+                                          </p:stCondLst>
+                                        </p:cTn>
+                                        <p:tgtEl>
+                                          <p:spTgt spid="44"/>
+                                        </p:tgtEl>
+                                        <p:attrNameLst>
+                                          <p:attrName>style.visibility</p:attrName>
+                                        </p:attrNameLst>
+                                      </p:cBhvr>
+                                      <p:to>
+                                        <p:strVal val="visible"/>
+                                      </p:to>
+                                    </p:set>
+                                    <p:animEffect transition="in" filter="fade">
+                                      <p:cBhvr>
+                                        <p:cTn id="141" dur="500"/>
+                                        <p:tgtEl>
+                                          <p:spTgt spid="44"/>
+                                        </p:tgtEl>
+                                      </p:cBhvr>
+                                    </p:animEffect>
+                                  </p:childTnLst>
+                                </p:cTn>
+                              </p:par>
+                              <p:par>
+                                <p:cTn id="145" presetID="10" presetClass="entr" presetSubtype="0" fill="hold" grpId="0" nodeType="withEffect">
+                                  <p:stCondLst>
+                                    <p:cond delay="450"/>
+                                  </p:stCondLst>
+                                  <p:childTnLst>
+                                    <p:set>
+                                      <p:cBhvr>
+                                        <p:cTn id="143" dur="1" fill="hold">
+                                          <p:stCondLst>
+                                            <p:cond delay="0"/>
+                                          </p:stCondLst>
+                                        </p:cTn>
+                                        <p:tgtEl>
+                                          <p:spTgt spid="45"/>
+                                        </p:tgtEl>
+                                        <p:attrNameLst>
+                                          <p:attrName>style.visibility</p:attrName>
+                                        </p:attrNameLst>
+                                      </p:cBhvr>
+                                      <p:to>
+                                        <p:strVal val="visible"/>
+                                      </p:to>
+                                    </p:set>
+                                    <p:animEffect transition="in" filter="fade">
+                                      <p:cBhvr>
+                                        <p:cTn id="144" dur="500"/>
+                                        <p:tgtEl>
+                                          <p:spTgt spid="45"/>
+                                        </p:tgtEl>
+                                      </p:cBhvr>
+                                    </p:animEffect>
+                                  </p:childTnLst>
+                                </p:cTn>
+                              </p:par>
+                            </p:childTnLst>
+                          </p:cTn>
+                        </p:par>
+                      </p:childTnLst>
+                    </p:cTn>
+                  </p:par>
+                  <p:par>
+                    <p:cTn id="146" fill="hold">
+                      <p:stCondLst>
+                        <p:cond delay="indefinite"/>
+                      </p:stCondLst>
+                      <p:childTnLst>
+                        <p:par>
+                          <p:cTn id="147" fill="hold">
+                            <p:stCondLst>
+                              <p:cond delay="0"/>
+                            </p:stCondLst>
+                            <p:childTnLst>
+                              <p:par>
+                                <p:cTn id="150" presetID="10" presetClass="entr" presetSubtype="0" fill="hold" grpId="0" nodeType="clickEffect">
+                                  <p:stCondLst>
+                                    <p:cond delay="0"/>
+                                  </p:stCondLst>
+                                  <p:childTnLst>
+                                    <p:set>
+                                      <p:cBhvr>
+                                        <p:cTn id="148" dur="1" fill="hold">
+                                          <p:stCondLst>
+                                            <p:cond delay="0"/>
+                                          </p:stCondLst>
+                                        </p:cTn>
+                                        <p:tgtEl>
+                                          <p:spTgt spid="46"/>
+                                        </p:tgtEl>
+                                        <p:attrNameLst>
+                                          <p:attrName>style.visibility</p:attrName>
+                                        </p:attrNameLst>
+                                      </p:cBhvr>
+                                      <p:to>
+                                        <p:strVal val="visible"/>
+                                      </p:to>
+                                    </p:set>
+                                    <p:animEffect transition="in" filter="fade">
+                                      <p:cBhvr>
+                                        <p:cTn id="149" dur="500"/>
+                                        <p:tgtEl>
+                                          <p:spTgt spid="46"/>
+                                        </p:tgtEl>
+                                      </p:cBhvr>
+                                    </p:animEffect>
+                                  </p:childTnLst>
+                                </p:cTn>
+                              </p:par>
+                            </p:childTnLst>
+                          </p:cTn>
+                        </p:par>
+                      </p:childTnLst>
+                    </p:cTn>
+                  </p:par>
+                  <p:par>
+                    <p:cTn id="151" fill="hold">
+                      <p:stCondLst>
+                        <p:cond delay="indefinite"/>
+                      </p:stCondLst>
+                      <p:childTnLst>
+                        <p:par>
+                          <p:cTn id="152" fill="hold">
+                            <p:stCondLst>
+                              <p:cond delay="0"/>
+                            </p:stCondLst>
+                            <p:childTnLst>
+                              <p:par>
+                                <p:cTn id="155" presetID="10" presetClass="entr" presetSubtype="0" fill="hold" grpId="0" nodeType="clickEffect">
+                                  <p:stCondLst>
+                                    <p:cond delay="0"/>
+                                  </p:stCondLst>
+                                  <p:childTnLst>
+                                    <p:set>
+                                      <p:cBhvr>
+                                        <p:cTn id="153" dur="1" fill="hold">
+                                          <p:stCondLst>
+                                            <p:cond delay="0"/>
+                                          </p:stCondLst>
+                                        </p:cTn>
+                                        <p:tgtEl>
+                                          <p:spTgt spid="47"/>
+                                        </p:tgtEl>
+                                        <p:attrNameLst>
+                                          <p:attrName>style.visibility</p:attrName>
+                                        </p:attrNameLst>
+                                      </p:cBhvr>
+                                      <p:to>
+                                        <p:strVal val="visible"/>
+                                      </p:to>
+                                    </p:set>
+                                    <p:animEffect transition="in" filter="fade">
+                                      <p:cBhvr>
+                                        <p:cTn id="154" dur="500"/>
+                                        <p:tgtEl>
+                                          <p:spTgt spid="47"/>
+                                        </p:tgtEl>
+                                      </p:cBhvr>
+                                    </p:animEffect>
+                                  </p:childTnLst>
+                                </p:cTn>
+                              </p:par>
+                            </p:childTnLst>
+                          </p:cTn>
+                        </p:par>
+                      </p:childTnLst>
+                    </p:cTn>
+                  </p:par>
+                  <p:par>
+                    <p:cTn id="156" fill="hold">
+                      <p:stCondLst>
+                        <p:cond delay="indefinite"/>
+                      </p:stCondLst>
+                      <p:childTnLst>
+                        <p:par>
+                          <p:cTn id="157" fill="hold">
+                            <p:stCondLst>
+                              <p:cond delay="0"/>
+                            </p:stCondLst>
+                            <p:childTnLst>
+                              <p:par>
+                                <p:cTn id="160" presetID="10" presetClass="entr" presetSubtype="0" fill="hold" grpId="0" nodeType="clickEffect">
+                                  <p:stCondLst>
+                                    <p:cond delay="0"/>
+                                  </p:stCondLst>
+                                  <p:childTnLst>
+                                    <p:set>
+                                      <p:cBhvr>
+                                        <p:cTn id="158" dur="1" fill="hold">
+                                          <p:stCondLst>
+                                            <p:cond delay="0"/>
+                                          </p:stCondLst>
+                                        </p:cTn>
+                                        <p:tgtEl>
+                                          <p:spTgt spid="48"/>
+                                        </p:tgtEl>
+                                        <p:attrNameLst>
+                                          <p:attrName>style.visibility</p:attrName>
+                                        </p:attrNameLst>
+                                      </p:cBhvr>
+                                      <p:to>
+                                        <p:strVal val="visible"/>
+                                      </p:to>
+                                    </p:set>
+                                    <p:animEffect transition="in" filter="fade">
+                                      <p:cBhvr>
+                                        <p:cTn id="159" dur="500"/>
+                                        <p:tgtEl>
+                                          <p:spTgt spid="48"/>
                                         </p:tgtEl>
                                       </p:cBhvr>
                                     </p:animEffect>
@@ -3555,6 +5136,16 @@
       <p:bldP spid="40" grpId="0" animBg="1"/>
       <p:bldP spid="41" grpId="0" animBg="1"/>
       <p:bldP spid="29" grpId="0" animBg="1"/>
+      <p:bldP spid="3" grpId="0"/>
+      <p:bldP spid="4" grpId="0"/>
+      <p:bldP spid="5" grpId="0"/>
+      <p:bldP spid="42" grpId="0"/>
+      <p:bldP spid="43" grpId="0"/>
+      <p:bldP spid="44" grpId="0"/>
+      <p:bldP spid="45" grpId="0" animBg="1"/>
+      <p:bldP spid="46" grpId="0" animBg="1"/>
+      <p:bldP spid="47" grpId="0" animBg="1"/>
+      <p:bldP spid="48" grpId="0" animBg="1"/>
     </p:bldLst>
   </p:timing>
 </p:sld>

</xml_diff>

<commit_message>
Split: slide 3 friction points restored, slide 4 federal rules
Co-Authored-By: Claude Sonnet 5.5 <noreply@anthropic.com>
</commit_message>
<xml_diff>
--- a/deck/journey/Friction_Click_Through.pptx
+++ b/deck/journey/Friction_Click_Through.pptx
@@ -508,11 +508,7 @@
 Click 3: Third, hunting instead of deciding. Benefits, eligibility, clinical policy, and provider systems sit in different places. No one view holds the full picture.
 Click 4: Fourth, decisions vary. Two reviewers can read the same packet and land in different places.
 Click 5: Fifth, the pend loop. A detail a cleaner read could have caught in minutes sends the packet back to the provider. The case starts from zero. This is the path you just watched.
-Click 6: Sixth, the member in the dark. John Doe waits for surgery and cannot see where his request stands. I am not trying to solve that one first. I will come back to it.
-Click 7: Here is why this is not just our problem. These frictions are now written into federal rules. Since January 2026, a decision is due in 72 hours for an expedited request and 7 calendar days for a standard one. That means an approval or a denial. Every denial needs a specific reason. And plans must publish their prior authorization results every year. The first report was due in March.
-Click 8: And a pend does not stop that clock. A plan can extend by up to 14 calendar days, but only if it justifies the delay as in the member's interest and tells the member in writing. So every avoidable pend is a documented delay, not a quiet pause.
-Click 9: Then in January 2027, about three months from now, four data interfaces go live. One of them, the Patient Access API, must show the member where a prior authorization stands. The member will finally have a window into the process.
-Click 10: So these are not just frictions we feel inside the process. Federal rules now set the clock, ask for the reason, and make the results public. Getting every case to a decision inside that clock matters more than ever.</a:t>
+Click 6: Sixth, the member in the dark. John Doe waits for surgery and cannot see where his request stands. I am not trying to solve that one first. I will come back to it.</a:t>
             </a:r>
             <a:endParaRPr lang="en-US" dirty="0"/>
           </a:p>
@@ -2748,548 +2744,6 @@
               <a:t>6</a:t>
             </a:r>
             <a:endParaRPr lang="en-US" sz="1100" dirty="0"/>
-          </a:p>
-        </p:txBody>
-      </p:sp>
-      <p:sp>
-        <p:nvSpPr>
-          <p:cNvPr id="42" name="titleB"/>
-          <p:cNvSpPr txBox="1"/>
-          <p:nvPr/>
-        </p:nvSpPr>
-        <p:spPr>
-          <a:xfrm>
-            <a:off x="457200" y="502920"/>
-            <a:ext cx="8229600" cy="685800"/>
-          </a:xfrm>
-          <a:prstGeom prst="rect">
-            <a:avLst/>
-          </a:prstGeom>
-          <a:noFill/>
-          <a:ln/>
-        </p:spPr>
-        <p:txBody>
-          <a:bodyPr wrap="square" lIns="0" tIns="0" rIns="0" bIns="0" rtlCol="0" anchor="ctr"/>
-          <a:lstStyle/>
-          <a:p>
-            <a:pPr algn="l" indent="0" marL="0">
-              <a:buNone/>
-            </a:pPr>
-            <a:r>
-              <a:rPr lang="en-US" sz="2600" dirty="0">
-                <a:solidFill>
-                  <a:srgbClr val="16211E"/>
-                </a:solidFill>
-                <a:latin typeface="Cambria" pitchFamily="34" charset="0"/>
-                <a:ea typeface="Cambria" pitchFamily="34" charset="-122"/>
-                <a:cs typeface="Cambria" pitchFamily="34" charset="-120"/>
-              </a:rPr>
-              <a:t>Federal rules now put a clock on all of this.</a:t>
-            </a:r>
-            <a:endParaRPr lang="en-US" sz="2600" dirty="0"/>
-          </a:p>
-        </p:txBody>
-      </p:sp>
-      <p:sp>
-        <p:nvSpPr>
-          <p:cNvPr id="43" name="subB"/>
-          <p:cNvSpPr txBox="1"/>
-          <p:nvPr/>
-        </p:nvSpPr>
-        <p:spPr>
-          <a:xfrm>
-            <a:off x="6675120" y="502920"/>
-            <a:ext cx="5056632" cy="685800"/>
-          </a:xfrm>
-          <a:prstGeom prst="rect">
-            <a:avLst/>
-          </a:prstGeom>
-          <a:noFill/>
-          <a:ln/>
-        </p:spPr>
-        <p:txBody>
-          <a:bodyPr wrap="square" lIns="0" tIns="0" rIns="0" bIns="0" rtlCol="0" anchor="ctr"/>
-          <a:lstStyle/>
-          <a:p>
-            <a:pPr algn="r" indent="0" marL="0">
-              <a:buNone/>
-            </a:pPr>
-            <a:r>
-              <a:rPr lang="en-US" sz="1400" dirty="0">
-                <a:solidFill>
-                  <a:srgbClr val="5C6B66"/>
-                </a:solidFill>
-                <a:latin typeface="Calibri" pitchFamily="34" charset="0"/>
-                <a:ea typeface="Calibri" pitchFamily="34" charset="-122"/>
-                <a:cs typeface="Calibri" pitchFamily="34" charset="-120"/>
-              </a:rPr>
-              <a:t>Applies to Medicare Advantage plans, including Humana's.</a:t>
-            </a:r>
-            <a:endParaRPr lang="en-US" sz="1400" dirty="0"/>
-          </a:p>
-        </p:txBody>
-      </p:sp>
-      <p:sp>
-        <p:nvSpPr>
-          <p:cNvPr id="44" name="footerB"/>
-          <p:cNvSpPr txBox="1"/>
-          <p:nvPr/>
-        </p:nvSpPr>
-        <p:spPr>
-          <a:xfrm>
-            <a:off x="457200" y="6492240"/>
-            <a:ext cx="11274552" cy="228600"/>
-          </a:xfrm>
-          <a:prstGeom prst="rect">
-            <a:avLst/>
-          </a:prstGeom>
-          <a:noFill/>
-          <a:ln/>
-        </p:spPr>
-        <p:txBody>
-          <a:bodyPr wrap="square" lIns="0" tIns="0" rIns="0" bIns="0" rtlCol="0" anchor="t"/>
-          <a:lstStyle/>
-          <a:p>
-            <a:pPr algn="l" indent="0" marL="0">
-              <a:buNone/>
-            </a:pPr>
-            <a:r>
-              <a:rPr lang="en-US" sz="900" dirty="0">
-                <a:solidFill>
-                  <a:srgbClr val="5C6B66"/>
-                </a:solidFill>
-                <a:latin typeface="Calibri" pitchFamily="34" charset="0"/>
-                <a:ea typeface="Calibri" pitchFamily="34" charset="-122"/>
-                <a:cs typeface="Calibri" pitchFamily="34" charset="-120"/>
-              </a:rPr>
-              <a:t>Sources: CMS-0057-F final rule and fact sheet (cms.gov). 42 CFR 422.568(b).</a:t>
-            </a:r>
-            <a:endParaRPr lang="en-US" sz="900" dirty="0"/>
-          </a:p>
-        </p:txBody>
-      </p:sp>
-      <p:sp>
-        <p:nvSpPr>
-          <p:cNvPr id="45" name="Fed1"/>
-          <p:cNvSpPr/>
-          <p:nvPr/>
-        </p:nvSpPr>
-        <p:spPr>
-          <a:xfrm>
-            <a:off x="457200" y="3090672"/>
-            <a:ext cx="3657600" cy="2331720"/>
-          </a:xfrm>
-          <a:prstGeom prst="roundRect">
-            <a:avLst>
-              <a:gd name="adj" fmla="val 3137"/>
-            </a:avLst>
-          </a:prstGeom>
-          <a:solidFill>
-            <a:srgbClr val="FFFFFF"/>
-          </a:solidFill>
-          <a:ln w="19050">
-            <a:solidFill>
-              <a:srgbClr val="B8452F"/>
-            </a:solidFill>
-          </a:ln>
-        </p:spPr>
-        <p:txBody>
-          <a:bodyPr wrap="square" lIns="164592" tIns="146304" rIns="164592" bIns="91440" rtlCol="0" anchor="t"/>
-          <a:lstStyle/>
-          <a:p>
-            <a:pPr algn="l" indent="0" marL="0">
-              <a:spcAft>
-                <a:spcPts val="400"/>
-              </a:spcAft>
-              <a:buNone/>
-            </a:pPr>
-            <a:r>
-              <a:rPr lang="en-US" sz="1000" b="1" spc="200" kern="0" dirty="0">
-                <a:solidFill>
-                  <a:srgbClr val="B8452F"/>
-                </a:solidFill>
-                <a:latin typeface="Calibri" pitchFamily="34" charset="0"/>
-                <a:ea typeface="Calibri" pitchFamily="34" charset="-122"/>
-                <a:cs typeface="Calibri" pitchFamily="34" charset="-120"/>
-              </a:rPr>
-              <a:t>IN EFFECT SINCE JANUARY 2026</a:t>
-            </a:r>
-            <a:endParaRPr lang="en-US" sz="1000" dirty="0"/>
-          </a:p>
-          <a:p>
-            <a:pPr algn="l" indent="0" marL="0">
-              <a:spcAft>
-                <a:spcPts val="800"/>
-              </a:spcAft>
-              <a:buNone/>
-            </a:pPr>
-            <a:r>
-              <a:rPr lang="en-US" sz="1600" b="1" dirty="0">
-                <a:solidFill>
-                  <a:srgbClr val="16211E"/>
-                </a:solidFill>
-                <a:latin typeface="Calibri" pitchFamily="34" charset="0"/>
-                <a:ea typeface="Calibri" pitchFamily="34" charset="-122"/>
-                <a:cs typeface="Calibri" pitchFamily="34" charset="-120"/>
-              </a:rPr>
-              <a:t>Decisions have a deadline</a:t>
-            </a:r>
-            <a:endParaRPr lang="en-US" sz="1000" dirty="0"/>
-          </a:p>
-          <a:p>
-            <a:pPr algn="l" marL="177800" indent="-177800">
-              <a:spcAft>
-                <a:spcPts val="500"/>
-              </a:spcAft>
-              <a:buSzPct val="100000"/>
-              <a:buChar char="•"/>
-            </a:pPr>
-            <a:r>
-              <a:rPr lang="en-US" sz="1250" dirty="0">
-                <a:solidFill>
-                  <a:srgbClr val="16211E"/>
-                </a:solidFill>
-                <a:latin typeface="Calibri" pitchFamily="34" charset="0"/>
-                <a:ea typeface="Calibri" pitchFamily="34" charset="-122"/>
-                <a:cs typeface="Calibri" pitchFamily="34" charset="-120"/>
-              </a:rPr>
-              <a:t>72 hours for expedited requests. 7 calendar days for standard ones. An approval or a denial, not a pend.</a:t>
-            </a:r>
-            <a:endParaRPr lang="en-US" sz="1000" dirty="0"/>
-          </a:p>
-          <a:p>
-            <a:pPr algn="l" marL="177800" indent="-177800">
-              <a:spcAft>
-                <a:spcPts val="500"/>
-              </a:spcAft>
-              <a:buSzPct val="100000"/>
-              <a:buChar char="•"/>
-            </a:pPr>
-            <a:r>
-              <a:rPr lang="en-US" sz="1250" dirty="0">
-                <a:solidFill>
-                  <a:srgbClr val="16211E"/>
-                </a:solidFill>
-                <a:latin typeface="Calibri" pitchFamily="34" charset="0"/>
-                <a:ea typeface="Calibri" pitchFamily="34" charset="-122"/>
-                <a:cs typeface="Calibri" pitchFamily="34" charset="-120"/>
-              </a:rPr>
-              <a:t>A specific reason on every denial.</a:t>
-            </a:r>
-            <a:endParaRPr lang="en-US" sz="1000" dirty="0"/>
-          </a:p>
-          <a:p>
-            <a:pPr algn="l" marL="177800" indent="-177800">
-              <a:spcAft>
-                <a:spcPts val="500"/>
-              </a:spcAft>
-              <a:buSzPct val="100000"/>
-              <a:buChar char="•"/>
-            </a:pPr>
-            <a:r>
-              <a:rPr lang="en-US" sz="1250" dirty="0">
-                <a:solidFill>
-                  <a:srgbClr val="16211E"/>
-                </a:solidFill>
-                <a:latin typeface="Calibri" pitchFamily="34" charset="0"/>
-                <a:ea typeface="Calibri" pitchFamily="34" charset="-122"/>
-                <a:cs typeface="Calibri" pitchFamily="34" charset="-120"/>
-              </a:rPr>
-              <a:t>Prior authorization results published every year. The first report was due March 31, 2026.</a:t>
-            </a:r>
-            <a:endParaRPr lang="en-US" sz="1000" dirty="0"/>
-          </a:p>
-        </p:txBody>
-      </p:sp>
-      <p:sp>
-        <p:nvSpPr>
-          <p:cNvPr id="46" name="Fed2"/>
-          <p:cNvSpPr/>
-          <p:nvPr/>
-        </p:nvSpPr>
-        <p:spPr>
-          <a:xfrm>
-            <a:off x="4265676" y="3090672"/>
-            <a:ext cx="3657600" cy="2331720"/>
-          </a:xfrm>
-          <a:prstGeom prst="roundRect">
-            <a:avLst>
-              <a:gd name="adj" fmla="val 3137"/>
-            </a:avLst>
-          </a:prstGeom>
-          <a:solidFill>
-            <a:srgbClr val="FFFFFF"/>
-          </a:solidFill>
-          <a:ln w="19050">
-            <a:solidFill>
-              <a:srgbClr val="8A5A00"/>
-            </a:solidFill>
-          </a:ln>
-        </p:spPr>
-        <p:txBody>
-          <a:bodyPr wrap="square" lIns="164592" tIns="146304" rIns="164592" bIns="91440" rtlCol="0" anchor="t"/>
-          <a:lstStyle/>
-          <a:p>
-            <a:pPr algn="l" indent="0" marL="0">
-              <a:spcAft>
-                <a:spcPts val="400"/>
-              </a:spcAft>
-              <a:buNone/>
-            </a:pPr>
-            <a:r>
-              <a:rPr lang="en-US" sz="1000" b="1" spc="200" kern="0" dirty="0">
-                <a:solidFill>
-                  <a:srgbClr val="8A5A00"/>
-                </a:solidFill>
-                <a:latin typeface="Calibri" pitchFamily="34" charset="0"/>
-                <a:ea typeface="Calibri" pitchFamily="34" charset="-122"/>
-                <a:cs typeface="Calibri" pitchFamily="34" charset="-120"/>
-              </a:rPr>
-              <a:t>THE RULE ON PENDING</a:t>
-            </a:r>
-            <a:endParaRPr lang="en-US" sz="1000" dirty="0"/>
-          </a:p>
-          <a:p>
-            <a:pPr algn="l" indent="0" marL="0">
-              <a:spcAft>
-                <a:spcPts val="800"/>
-              </a:spcAft>
-              <a:buNone/>
-            </a:pPr>
-            <a:r>
-              <a:rPr lang="en-US" sz="1600" b="1" dirty="0">
-                <a:solidFill>
-                  <a:srgbClr val="16211E"/>
-                </a:solidFill>
-                <a:latin typeface="Calibri" pitchFamily="34" charset="0"/>
-                <a:ea typeface="Calibri" pitchFamily="34" charset="-122"/>
-                <a:cs typeface="Calibri" pitchFamily="34" charset="-120"/>
-              </a:rPr>
-              <a:t>A pend does not stop the clock</a:t>
-            </a:r>
-            <a:endParaRPr lang="en-US" sz="1000" dirty="0"/>
-          </a:p>
-          <a:p>
-            <a:pPr algn="l" marL="177800" indent="-177800">
-              <a:spcAft>
-                <a:spcPts val="500"/>
-              </a:spcAft>
-              <a:buSzPct val="100000"/>
-              <a:buChar char="•"/>
-            </a:pPr>
-            <a:r>
-              <a:rPr lang="en-US" sz="1250" dirty="0">
-                <a:solidFill>
-                  <a:srgbClr val="16211E"/>
-                </a:solidFill>
-                <a:latin typeface="Calibri" pitchFamily="34" charset="0"/>
-                <a:ea typeface="Calibri" pitchFamily="34" charset="-122"/>
-                <a:cs typeface="Calibri" pitchFamily="34" charset="-120"/>
-              </a:rPr>
-              <a:t>Asking the provider for more information does not pause it.</a:t>
-            </a:r>
-            <a:endParaRPr lang="en-US" sz="1000" dirty="0"/>
-          </a:p>
-          <a:p>
-            <a:pPr algn="l" marL="177800" indent="-177800">
-              <a:spcAft>
-                <a:spcPts val="500"/>
-              </a:spcAft>
-              <a:buSzPct val="100000"/>
-              <a:buChar char="•"/>
-            </a:pPr>
-            <a:r>
-              <a:rPr lang="en-US" sz="1250" dirty="0">
-                <a:solidFill>
-                  <a:srgbClr val="16211E"/>
-                </a:solidFill>
-                <a:latin typeface="Calibri" pitchFamily="34" charset="0"/>
-                <a:ea typeface="Calibri" pitchFamily="34" charset="-122"/>
-                <a:cs typeface="Calibri" pitchFamily="34" charset="-120"/>
-              </a:rPr>
-              <a:t>The plan may extend by up to 14 calendar days.</a:t>
-            </a:r>
-            <a:endParaRPr lang="en-US" sz="1000" dirty="0"/>
-          </a:p>
-          <a:p>
-            <a:pPr algn="l" marL="177800" indent="-177800">
-              <a:spcAft>
-                <a:spcPts val="500"/>
-              </a:spcAft>
-              <a:buSzPct val="100000"/>
-              <a:buChar char="•"/>
-            </a:pPr>
-            <a:r>
-              <a:rPr lang="en-US" sz="1250" dirty="0">
-                <a:solidFill>
-                  <a:srgbClr val="16211E"/>
-                </a:solidFill>
-                <a:latin typeface="Calibri" pitchFamily="34" charset="0"/>
-                <a:ea typeface="Calibri" pitchFamily="34" charset="-122"/>
-                <a:cs typeface="Calibri" pitchFamily="34" charset="-120"/>
-              </a:rPr>
-              <a:t>Only if it justifies the delay as in the member's interest, and tells the member in writing.</a:t>
-            </a:r>
-            <a:endParaRPr lang="en-US" sz="1000" dirty="0"/>
-          </a:p>
-        </p:txBody>
-      </p:sp>
-      <p:sp>
-        <p:nvSpPr>
-          <p:cNvPr id="47" name="Fed3"/>
-          <p:cNvSpPr/>
-          <p:nvPr/>
-        </p:nvSpPr>
-        <p:spPr>
-          <a:xfrm>
-            <a:off x="8074152" y="3090672"/>
-            <a:ext cx="3657600" cy="2331720"/>
-          </a:xfrm>
-          <a:prstGeom prst="roundRect">
-            <a:avLst>
-              <a:gd name="adj" fmla="val 3137"/>
-            </a:avLst>
-          </a:prstGeom>
-          <a:solidFill>
-            <a:srgbClr val="FFFFFF"/>
-          </a:solidFill>
-          <a:ln w="19050">
-            <a:solidFill>
-              <a:srgbClr val="5F3AA8"/>
-            </a:solidFill>
-          </a:ln>
-        </p:spPr>
-        <p:txBody>
-          <a:bodyPr wrap="square" lIns="164592" tIns="146304" rIns="164592" bIns="91440" rtlCol="0" anchor="t"/>
-          <a:lstStyle/>
-          <a:p>
-            <a:pPr algn="l" indent="0" marL="0">
-              <a:spcAft>
-                <a:spcPts val="400"/>
-              </a:spcAft>
-              <a:buNone/>
-            </a:pPr>
-            <a:r>
-              <a:rPr lang="en-US" sz="1000" b="1" spc="200" kern="0" dirty="0">
-                <a:solidFill>
-                  <a:srgbClr val="5F3AA8"/>
-                </a:solidFill>
-                <a:latin typeface="Calibri" pitchFamily="34" charset="0"/>
-                <a:ea typeface="Calibri" pitchFamily="34" charset="-122"/>
-                <a:cs typeface="Calibri" pitchFamily="34" charset="-120"/>
-              </a:rPr>
-              <a:t>COMING JANUARY 2027</a:t>
-            </a:r>
-            <a:endParaRPr lang="en-US" sz="1000" dirty="0"/>
-          </a:p>
-          <a:p>
-            <a:pPr algn="l" indent="0" marL="0">
-              <a:spcAft>
-                <a:spcPts val="800"/>
-              </a:spcAft>
-              <a:buNone/>
-            </a:pPr>
-            <a:r>
-              <a:rPr lang="en-US" sz="1600" b="1" dirty="0">
-                <a:solidFill>
-                  <a:srgbClr val="16211E"/>
-                </a:solidFill>
-                <a:latin typeface="Calibri" pitchFamily="34" charset="0"/>
-                <a:ea typeface="Calibri" pitchFamily="34" charset="-122"/>
-                <a:cs typeface="Calibri" pitchFamily="34" charset="-120"/>
-              </a:rPr>
-              <a:t>The member gets a window</a:t>
-            </a:r>
-            <a:endParaRPr lang="en-US" sz="1000" dirty="0"/>
-          </a:p>
-          <a:p>
-            <a:pPr algn="l" marL="177800" indent="-177800">
-              <a:spcAft>
-                <a:spcPts val="500"/>
-              </a:spcAft>
-              <a:buSzPct val="100000"/>
-              <a:buChar char="•"/>
-            </a:pPr>
-            <a:r>
-              <a:rPr lang="en-US" sz="1250" dirty="0">
-                <a:solidFill>
-                  <a:srgbClr val="16211E"/>
-                </a:solidFill>
-                <a:latin typeface="Calibri" pitchFamily="34" charset="0"/>
-                <a:ea typeface="Calibri" pitchFamily="34" charset="-122"/>
-                <a:cs typeface="Calibri" pitchFamily="34" charset="-120"/>
-              </a:rPr>
-              <a:t>Four data interfaces (FHIR APIs) go live.</a:t>
-            </a:r>
-            <a:endParaRPr lang="en-US" sz="1000" dirty="0"/>
-          </a:p>
-          <a:p>
-            <a:pPr algn="l" marL="177800" indent="-177800">
-              <a:spcAft>
-                <a:spcPts val="500"/>
-              </a:spcAft>
-              <a:buSzPct val="100000"/>
-              <a:buChar char="•"/>
-            </a:pPr>
-            <a:r>
-              <a:rPr lang="en-US" sz="1250" dirty="0">
-                <a:solidFill>
-                  <a:srgbClr val="16211E"/>
-                </a:solidFill>
-                <a:latin typeface="Calibri" pitchFamily="34" charset="0"/>
-                <a:ea typeface="Calibri" pitchFamily="34" charset="-122"/>
-                <a:cs typeface="Calibri" pitchFamily="34" charset="-120"/>
-              </a:rPr>
-              <a:t>One of them, the Patient Access API, must show the member where a prior authorization stands.</a:t>
-            </a:r>
-            <a:endParaRPr lang="en-US" sz="1000" dirty="0"/>
-          </a:p>
-        </p:txBody>
-      </p:sp>
-      <p:sp>
-        <p:nvSpPr>
-          <p:cNvPr id="48" name="Banner"/>
-          <p:cNvSpPr/>
-          <p:nvPr/>
-        </p:nvSpPr>
-        <p:spPr>
-          <a:xfrm>
-            <a:off x="457200" y="5577840"/>
-            <a:ext cx="11274552" cy="731520"/>
-          </a:xfrm>
-          <a:prstGeom prst="roundRect">
-            <a:avLst>
-              <a:gd name="adj" fmla="val 10000"/>
-            </a:avLst>
-          </a:prstGeom>
-          <a:solidFill>
-            <a:srgbClr val="1F6F5C"/>
-          </a:solidFill>
-          <a:ln w="12700">
-            <a:solidFill>
-              <a:srgbClr val="1F6F5C"/>
-            </a:solidFill>
-          </a:ln>
-        </p:spPr>
-        <p:txBody>
-          <a:bodyPr wrap="square" lIns="228600" tIns="54864" rIns="228600" bIns="54864" rtlCol="0" anchor="ctr"/>
-          <a:lstStyle/>
-          <a:p>
-            <a:pPr algn="l" indent="0" marL="0">
-              <a:buNone/>
-            </a:pPr>
-            <a:r>
-              <a:rPr lang="en-US" sz="1400" b="1" dirty="0">
-                <a:solidFill>
-                  <a:srgbClr val="FFFFFF"/>
-                </a:solidFill>
-                <a:latin typeface="Calibri" pitchFamily="34" charset="0"/>
-                <a:ea typeface="Calibri" pitchFamily="34" charset="-122"/>
-                <a:cs typeface="Calibri" pitchFamily="34" charset="-120"/>
-              </a:rPr>
-              <a:t>These are not just frictions we feel. Federal rules now set the clock, ask for the reason, and make the results public. Getting every case to a decision inside that clock matters more than ever.</a:t>
-            </a:r>
-            <a:endParaRPr lang="en-US" sz="1400" dirty="0"/>
           </a:p>
         </p:txBody>
       </p:sp>
@@ -4044,1058 +3498,6 @@
                       </p:childTnLst>
                     </p:cTn>
                   </p:par>
-                  <p:par>
-                    <p:cTn id="69" fill="hold">
-                      <p:stCondLst>
-                        <p:cond delay="indefinite"/>
-                      </p:stCondLst>
-                      <p:childTnLst>
-                        <p:par>
-                          <p:cTn id="70" fill="hold">
-                            <p:stCondLst>
-                              <p:cond delay="0"/>
-                            </p:stCondLst>
-                            <p:childTnLst>
-                              <p:par>
-                                <p:cTn id="73" presetID="10" presetClass="exit" presetSubtype="0" fill="hold" grpId="0" nodeType="clickEffect">
-                                  <p:stCondLst>
-                                    <p:cond delay="0"/>
-                                  </p:stCondLst>
-                                  <p:childTnLst>
-                                    <p:animEffect transition="out" filter="fade">
-                                      <p:cBhvr>
-                                        <p:cTn id="71" dur="300"/>
-                                        <p:tgtEl>
-                                          <p:spTgt spid="30"/>
-                                        </p:tgtEl>
-                                      </p:cBhvr>
-                                    </p:animEffect>
-                                    <p:set>
-                                      <p:cBhvr>
-                                        <p:cTn id="72" dur="1" fill="hold">
-                                          <p:stCondLst>
-                                            <p:cond delay="299"/>
-                                          </p:stCondLst>
-                                        </p:cTn>
-                                        <p:tgtEl>
-                                          <p:spTgt spid="30"/>
-                                        </p:tgtEl>
-                                        <p:attrNameLst>
-                                          <p:attrName>style.visibility</p:attrName>
-                                        </p:attrNameLst>
-                                      </p:cBhvr>
-                                      <p:to>
-                                        <p:strVal val="hidden"/>
-                                      </p:to>
-                                    </p:set>
-                                  </p:childTnLst>
-                                </p:cTn>
-                              </p:par>
-                              <p:par>
-                                <p:cTn id="76" presetID="10" presetClass="exit" presetSubtype="0" fill="hold" grpId="0" nodeType="withEffect">
-                                  <p:stCondLst>
-                                    <p:cond delay="0"/>
-                                  </p:stCondLst>
-                                  <p:childTnLst>
-                                    <p:animEffect transition="out" filter="fade">
-                                      <p:cBhvr>
-                                        <p:cTn id="74" dur="300"/>
-                                        <p:tgtEl>
-                                          <p:spTgt spid="31"/>
-                                        </p:tgtEl>
-                                      </p:cBhvr>
-                                    </p:animEffect>
-                                    <p:set>
-                                      <p:cBhvr>
-                                        <p:cTn id="75" dur="1" fill="hold">
-                                          <p:stCondLst>
-                                            <p:cond delay="299"/>
-                                          </p:stCondLst>
-                                        </p:cTn>
-                                        <p:tgtEl>
-                                          <p:spTgt spid="31"/>
-                                        </p:tgtEl>
-                                        <p:attrNameLst>
-                                          <p:attrName>style.visibility</p:attrName>
-                                        </p:attrNameLst>
-                                      </p:cBhvr>
-                                      <p:to>
-                                        <p:strVal val="hidden"/>
-                                      </p:to>
-                                    </p:set>
-                                  </p:childTnLst>
-                                </p:cTn>
-                              </p:par>
-                              <p:par>
-                                <p:cTn id="79" presetID="10" presetClass="exit" presetSubtype="0" fill="hold" grpId="0" nodeType="withEffect">
-                                  <p:stCondLst>
-                                    <p:cond delay="0"/>
-                                  </p:stCondLst>
-                                  <p:childTnLst>
-                                    <p:animEffect transition="out" filter="fade">
-                                      <p:cBhvr>
-                                        <p:cTn id="77" dur="300"/>
-                                        <p:tgtEl>
-                                          <p:spTgt spid="24"/>
-                                        </p:tgtEl>
-                                      </p:cBhvr>
-                                    </p:animEffect>
-                                    <p:set>
-                                      <p:cBhvr>
-                                        <p:cTn id="78" dur="1" fill="hold">
-                                          <p:stCondLst>
-                                            <p:cond delay="299"/>
-                                          </p:stCondLst>
-                                        </p:cTn>
-                                        <p:tgtEl>
-                                          <p:spTgt spid="24"/>
-                                        </p:tgtEl>
-                                        <p:attrNameLst>
-                                          <p:attrName>style.visibility</p:attrName>
-                                        </p:attrNameLst>
-                                      </p:cBhvr>
-                                      <p:to>
-                                        <p:strVal val="hidden"/>
-                                      </p:to>
-                                    </p:set>
-                                  </p:childTnLst>
-                                </p:cTn>
-                              </p:par>
-                              <p:par>
-                                <p:cTn id="82" presetID="10" presetClass="exit" presetSubtype="0" fill="hold" grpId="0" nodeType="withEffect">
-                                  <p:stCondLst>
-                                    <p:cond delay="0"/>
-                                  </p:stCondLst>
-                                  <p:childTnLst>
-                                    <p:animEffect transition="out" filter="fade">
-                                      <p:cBhvr>
-                                        <p:cTn id="80" dur="300"/>
-                                        <p:tgtEl>
-                                          <p:spTgt spid="32"/>
-                                        </p:tgtEl>
-                                      </p:cBhvr>
-                                    </p:animEffect>
-                                    <p:set>
-                                      <p:cBhvr>
-                                        <p:cTn id="81" dur="1" fill="hold">
-                                          <p:stCondLst>
-                                            <p:cond delay="299"/>
-                                          </p:stCondLst>
-                                        </p:cTn>
-                                        <p:tgtEl>
-                                          <p:spTgt spid="32"/>
-                                        </p:tgtEl>
-                                        <p:attrNameLst>
-                                          <p:attrName>style.visibility</p:attrName>
-                                        </p:attrNameLst>
-                                      </p:cBhvr>
-                                      <p:to>
-                                        <p:strVal val="hidden"/>
-                                      </p:to>
-                                    </p:set>
-                                  </p:childTnLst>
-                                </p:cTn>
-                              </p:par>
-                              <p:par>
-                                <p:cTn id="85" presetID="10" presetClass="exit" presetSubtype="0" fill="hold" grpId="0" nodeType="withEffect">
-                                  <p:stCondLst>
-                                    <p:cond delay="0"/>
-                                  </p:stCondLst>
-                                  <p:childTnLst>
-                                    <p:animEffect transition="out" filter="fade">
-                                      <p:cBhvr>
-                                        <p:cTn id="83" dur="300"/>
-                                        <p:tgtEl>
-                                          <p:spTgt spid="33"/>
-                                        </p:tgtEl>
-                                      </p:cBhvr>
-                                    </p:animEffect>
-                                    <p:set>
-                                      <p:cBhvr>
-                                        <p:cTn id="84" dur="1" fill="hold">
-                                          <p:stCondLst>
-                                            <p:cond delay="299"/>
-                                          </p:stCondLst>
-                                        </p:cTn>
-                                        <p:tgtEl>
-                                          <p:spTgt spid="33"/>
-                                        </p:tgtEl>
-                                        <p:attrNameLst>
-                                          <p:attrName>style.visibility</p:attrName>
-                                        </p:attrNameLst>
-                                      </p:cBhvr>
-                                      <p:to>
-                                        <p:strVal val="hidden"/>
-                                      </p:to>
-                                    </p:set>
-                                  </p:childTnLst>
-                                </p:cTn>
-                              </p:par>
-                              <p:par>
-                                <p:cTn id="88" presetID="10" presetClass="exit" presetSubtype="0" fill="hold" grpId="0" nodeType="withEffect">
-                                  <p:stCondLst>
-                                    <p:cond delay="0"/>
-                                  </p:stCondLst>
-                                  <p:childTnLst>
-                                    <p:animEffect transition="out" filter="fade">
-                                      <p:cBhvr>
-                                        <p:cTn id="86" dur="300"/>
-                                        <p:tgtEl>
-                                          <p:spTgt spid="26"/>
-                                        </p:tgtEl>
-                                      </p:cBhvr>
-                                    </p:animEffect>
-                                    <p:set>
-                                      <p:cBhvr>
-                                        <p:cTn id="87" dur="1" fill="hold">
-                                          <p:stCondLst>
-                                            <p:cond delay="299"/>
-                                          </p:stCondLst>
-                                        </p:cTn>
-                                        <p:tgtEl>
-                                          <p:spTgt spid="26"/>
-                                        </p:tgtEl>
-                                        <p:attrNameLst>
-                                          <p:attrName>style.visibility</p:attrName>
-                                        </p:attrNameLst>
-                                      </p:cBhvr>
-                                      <p:to>
-                                        <p:strVal val="hidden"/>
-                                      </p:to>
-                                    </p:set>
-                                  </p:childTnLst>
-                                </p:cTn>
-                              </p:par>
-                              <p:par>
-                                <p:cTn id="91" presetID="10" presetClass="exit" presetSubtype="0" fill="hold" grpId="0" nodeType="withEffect">
-                                  <p:stCondLst>
-                                    <p:cond delay="0"/>
-                                  </p:stCondLst>
-                                  <p:childTnLst>
-                                    <p:animEffect transition="out" filter="fade">
-                                      <p:cBhvr>
-                                        <p:cTn id="89" dur="300"/>
-                                        <p:tgtEl>
-                                          <p:spTgt spid="34"/>
-                                        </p:tgtEl>
-                                      </p:cBhvr>
-                                    </p:animEffect>
-                                    <p:set>
-                                      <p:cBhvr>
-                                        <p:cTn id="90" dur="1" fill="hold">
-                                          <p:stCondLst>
-                                            <p:cond delay="299"/>
-                                          </p:stCondLst>
-                                        </p:cTn>
-                                        <p:tgtEl>
-                                          <p:spTgt spid="34"/>
-                                        </p:tgtEl>
-                                        <p:attrNameLst>
-                                          <p:attrName>style.visibility</p:attrName>
-                                        </p:attrNameLst>
-                                      </p:cBhvr>
-                                      <p:to>
-                                        <p:strVal val="hidden"/>
-                                      </p:to>
-                                    </p:set>
-                                  </p:childTnLst>
-                                </p:cTn>
-                              </p:par>
-                              <p:par>
-                                <p:cTn id="94" presetID="10" presetClass="exit" presetSubtype="0" fill="hold" grpId="0" nodeType="withEffect">
-                                  <p:stCondLst>
-                                    <p:cond delay="0"/>
-                                  </p:stCondLst>
-                                  <p:childTnLst>
-                                    <p:animEffect transition="out" filter="fade">
-                                      <p:cBhvr>
-                                        <p:cTn id="92" dur="300"/>
-                                        <p:tgtEl>
-                                          <p:spTgt spid="35"/>
-                                        </p:tgtEl>
-                                      </p:cBhvr>
-                                    </p:animEffect>
-                                    <p:set>
-                                      <p:cBhvr>
-                                        <p:cTn id="93" dur="1" fill="hold">
-                                          <p:stCondLst>
-                                            <p:cond delay="299"/>
-                                          </p:stCondLst>
-                                        </p:cTn>
-                                        <p:tgtEl>
-                                          <p:spTgt spid="35"/>
-                                        </p:tgtEl>
-                                        <p:attrNameLst>
-                                          <p:attrName>style.visibility</p:attrName>
-                                        </p:attrNameLst>
-                                      </p:cBhvr>
-                                      <p:to>
-                                        <p:strVal val="hidden"/>
-                                      </p:to>
-                                    </p:set>
-                                  </p:childTnLst>
-                                </p:cTn>
-                              </p:par>
-                              <p:par>
-                                <p:cTn id="97" presetID="10" presetClass="exit" presetSubtype="0" fill="hold" grpId="0" nodeType="withEffect">
-                                  <p:stCondLst>
-                                    <p:cond delay="0"/>
-                                  </p:stCondLst>
-                                  <p:childTnLst>
-                                    <p:animEffect transition="out" filter="fade">
-                                      <p:cBhvr>
-                                        <p:cTn id="95" dur="300"/>
-                                        <p:tgtEl>
-                                          <p:spTgt spid="25"/>
-                                        </p:tgtEl>
-                                      </p:cBhvr>
-                                    </p:animEffect>
-                                    <p:set>
-                                      <p:cBhvr>
-                                        <p:cTn id="96" dur="1" fill="hold">
-                                          <p:stCondLst>
-                                            <p:cond delay="299"/>
-                                          </p:stCondLst>
-                                        </p:cTn>
-                                        <p:tgtEl>
-                                          <p:spTgt spid="25"/>
-                                        </p:tgtEl>
-                                        <p:attrNameLst>
-                                          <p:attrName>style.visibility</p:attrName>
-                                        </p:attrNameLst>
-                                      </p:cBhvr>
-                                      <p:to>
-                                        <p:strVal val="hidden"/>
-                                      </p:to>
-                                    </p:set>
-                                  </p:childTnLst>
-                                </p:cTn>
-                              </p:par>
-                              <p:par>
-                                <p:cTn id="100" presetID="10" presetClass="exit" presetSubtype="0" fill="hold" grpId="0" nodeType="withEffect">
-                                  <p:stCondLst>
-                                    <p:cond delay="0"/>
-                                  </p:stCondLst>
-                                  <p:childTnLst>
-                                    <p:animEffect transition="out" filter="fade">
-                                      <p:cBhvr>
-                                        <p:cTn id="98" dur="300"/>
-                                        <p:tgtEl>
-                                          <p:spTgt spid="36"/>
-                                        </p:tgtEl>
-                                      </p:cBhvr>
-                                    </p:animEffect>
-                                    <p:set>
-                                      <p:cBhvr>
-                                        <p:cTn id="99" dur="1" fill="hold">
-                                          <p:stCondLst>
-                                            <p:cond delay="299"/>
-                                          </p:stCondLst>
-                                        </p:cTn>
-                                        <p:tgtEl>
-                                          <p:spTgt spid="36"/>
-                                        </p:tgtEl>
-                                        <p:attrNameLst>
-                                          <p:attrName>style.visibility</p:attrName>
-                                        </p:attrNameLst>
-                                      </p:cBhvr>
-                                      <p:to>
-                                        <p:strVal val="hidden"/>
-                                      </p:to>
-                                    </p:set>
-                                  </p:childTnLst>
-                                </p:cTn>
-                              </p:par>
-                              <p:par>
-                                <p:cTn id="103" presetID="10" presetClass="exit" presetSubtype="0" fill="hold" grpId="0" nodeType="withEffect">
-                                  <p:stCondLst>
-                                    <p:cond delay="0"/>
-                                  </p:stCondLst>
-                                  <p:childTnLst>
-                                    <p:animEffect transition="out" filter="fade">
-                                      <p:cBhvr>
-                                        <p:cTn id="101" dur="300"/>
-                                        <p:tgtEl>
-                                          <p:spTgt spid="37"/>
-                                        </p:tgtEl>
-                                      </p:cBhvr>
-                                    </p:animEffect>
-                                    <p:set>
-                                      <p:cBhvr>
-                                        <p:cTn id="102" dur="1" fill="hold">
-                                          <p:stCondLst>
-                                            <p:cond delay="299"/>
-                                          </p:stCondLst>
-                                        </p:cTn>
-                                        <p:tgtEl>
-                                          <p:spTgt spid="37"/>
-                                        </p:tgtEl>
-                                        <p:attrNameLst>
-                                          <p:attrName>style.visibility</p:attrName>
-                                        </p:attrNameLst>
-                                      </p:cBhvr>
-                                      <p:to>
-                                        <p:strVal val="hidden"/>
-                                      </p:to>
-                                    </p:set>
-                                  </p:childTnLst>
-                                </p:cTn>
-                              </p:par>
-                              <p:par>
-                                <p:cTn id="106" presetID="10" presetClass="exit" presetSubtype="0" fill="hold" grpId="0" nodeType="withEffect">
-                                  <p:stCondLst>
-                                    <p:cond delay="0"/>
-                                  </p:stCondLst>
-                                  <p:childTnLst>
-                                    <p:animEffect transition="out" filter="fade">
-                                      <p:cBhvr>
-                                        <p:cTn id="104" dur="300"/>
-                                        <p:tgtEl>
-                                          <p:spTgt spid="27"/>
-                                        </p:tgtEl>
-                                      </p:cBhvr>
-                                    </p:animEffect>
-                                    <p:set>
-                                      <p:cBhvr>
-                                        <p:cTn id="105" dur="1" fill="hold">
-                                          <p:stCondLst>
-                                            <p:cond delay="299"/>
-                                          </p:stCondLst>
-                                        </p:cTn>
-                                        <p:tgtEl>
-                                          <p:spTgt spid="27"/>
-                                        </p:tgtEl>
-                                        <p:attrNameLst>
-                                          <p:attrName>style.visibility</p:attrName>
-                                        </p:attrNameLst>
-                                      </p:cBhvr>
-                                      <p:to>
-                                        <p:strVal val="hidden"/>
-                                      </p:to>
-                                    </p:set>
-                                  </p:childTnLst>
-                                </p:cTn>
-                              </p:par>
-                              <p:par>
-                                <p:cTn id="109" presetID="10" presetClass="exit" presetSubtype="0" fill="hold" grpId="0" nodeType="withEffect">
-                                  <p:stCondLst>
-                                    <p:cond delay="0"/>
-                                  </p:stCondLst>
-                                  <p:childTnLst>
-                                    <p:animEffect transition="out" filter="fade">
-                                      <p:cBhvr>
-                                        <p:cTn id="107" dur="300"/>
-                                        <p:tgtEl>
-                                          <p:spTgt spid="38"/>
-                                        </p:tgtEl>
-                                      </p:cBhvr>
-                                    </p:animEffect>
-                                    <p:set>
-                                      <p:cBhvr>
-                                        <p:cTn id="108" dur="1" fill="hold">
-                                          <p:stCondLst>
-                                            <p:cond delay="299"/>
-                                          </p:stCondLst>
-                                        </p:cTn>
-                                        <p:tgtEl>
-                                          <p:spTgt spid="38"/>
-                                        </p:tgtEl>
-                                        <p:attrNameLst>
-                                          <p:attrName>style.visibility</p:attrName>
-                                        </p:attrNameLst>
-                                      </p:cBhvr>
-                                      <p:to>
-                                        <p:strVal val="hidden"/>
-                                      </p:to>
-                                    </p:set>
-                                  </p:childTnLst>
-                                </p:cTn>
-                              </p:par>
-                              <p:par>
-                                <p:cTn id="112" presetID="10" presetClass="exit" presetSubtype="0" fill="hold" grpId="0" nodeType="withEffect">
-                                  <p:stCondLst>
-                                    <p:cond delay="0"/>
-                                  </p:stCondLst>
-                                  <p:childTnLst>
-                                    <p:animEffect transition="out" filter="fade">
-                                      <p:cBhvr>
-                                        <p:cTn id="110" dur="300"/>
-                                        <p:tgtEl>
-                                          <p:spTgt spid="39"/>
-                                        </p:tgtEl>
-                                      </p:cBhvr>
-                                    </p:animEffect>
-                                    <p:set>
-                                      <p:cBhvr>
-                                        <p:cTn id="111" dur="1" fill="hold">
-                                          <p:stCondLst>
-                                            <p:cond delay="299"/>
-                                          </p:stCondLst>
-                                        </p:cTn>
-                                        <p:tgtEl>
-                                          <p:spTgt spid="39"/>
-                                        </p:tgtEl>
-                                        <p:attrNameLst>
-                                          <p:attrName>style.visibility</p:attrName>
-                                        </p:attrNameLst>
-                                      </p:cBhvr>
-                                      <p:to>
-                                        <p:strVal val="hidden"/>
-                                      </p:to>
-                                    </p:set>
-                                  </p:childTnLst>
-                                </p:cTn>
-                              </p:par>
-                              <p:par>
-                                <p:cTn id="115" presetID="10" presetClass="exit" presetSubtype="0" fill="hold" grpId="0" nodeType="withEffect">
-                                  <p:stCondLst>
-                                    <p:cond delay="0"/>
-                                  </p:stCondLst>
-                                  <p:childTnLst>
-                                    <p:animEffect transition="out" filter="fade">
-                                      <p:cBhvr>
-                                        <p:cTn id="113" dur="300"/>
-                                        <p:tgtEl>
-                                          <p:spTgt spid="28"/>
-                                        </p:tgtEl>
-                                      </p:cBhvr>
-                                    </p:animEffect>
-                                    <p:set>
-                                      <p:cBhvr>
-                                        <p:cTn id="114" dur="1" fill="hold">
-                                          <p:stCondLst>
-                                            <p:cond delay="299"/>
-                                          </p:stCondLst>
-                                        </p:cTn>
-                                        <p:tgtEl>
-                                          <p:spTgt spid="28"/>
-                                        </p:tgtEl>
-                                        <p:attrNameLst>
-                                          <p:attrName>style.visibility</p:attrName>
-                                        </p:attrNameLst>
-                                      </p:cBhvr>
-                                      <p:to>
-                                        <p:strVal val="hidden"/>
-                                      </p:to>
-                                    </p:set>
-                                  </p:childTnLst>
-                                </p:cTn>
-                              </p:par>
-                              <p:par>
-                                <p:cTn id="118" presetID="10" presetClass="exit" presetSubtype="0" fill="hold" grpId="0" nodeType="withEffect">
-                                  <p:stCondLst>
-                                    <p:cond delay="0"/>
-                                  </p:stCondLst>
-                                  <p:childTnLst>
-                                    <p:animEffect transition="out" filter="fade">
-                                      <p:cBhvr>
-                                        <p:cTn id="116" dur="300"/>
-                                        <p:tgtEl>
-                                          <p:spTgt spid="40"/>
-                                        </p:tgtEl>
-                                      </p:cBhvr>
-                                    </p:animEffect>
-                                    <p:set>
-                                      <p:cBhvr>
-                                        <p:cTn id="117" dur="1" fill="hold">
-                                          <p:stCondLst>
-                                            <p:cond delay="299"/>
-                                          </p:stCondLst>
-                                        </p:cTn>
-                                        <p:tgtEl>
-                                          <p:spTgt spid="40"/>
-                                        </p:tgtEl>
-                                        <p:attrNameLst>
-                                          <p:attrName>style.visibility</p:attrName>
-                                        </p:attrNameLst>
-                                      </p:cBhvr>
-                                      <p:to>
-                                        <p:strVal val="hidden"/>
-                                      </p:to>
-                                    </p:set>
-                                  </p:childTnLst>
-                                </p:cTn>
-                              </p:par>
-                              <p:par>
-                                <p:cTn id="121" presetID="10" presetClass="exit" presetSubtype="0" fill="hold" grpId="0" nodeType="withEffect">
-                                  <p:stCondLst>
-                                    <p:cond delay="0"/>
-                                  </p:stCondLst>
-                                  <p:childTnLst>
-                                    <p:animEffect transition="out" filter="fade">
-                                      <p:cBhvr>
-                                        <p:cTn id="119" dur="300"/>
-                                        <p:tgtEl>
-                                          <p:spTgt spid="41"/>
-                                        </p:tgtEl>
-                                      </p:cBhvr>
-                                    </p:animEffect>
-                                    <p:set>
-                                      <p:cBhvr>
-                                        <p:cTn id="120" dur="1" fill="hold">
-                                          <p:stCondLst>
-                                            <p:cond delay="299"/>
-                                          </p:stCondLst>
-                                        </p:cTn>
-                                        <p:tgtEl>
-                                          <p:spTgt spid="41"/>
-                                        </p:tgtEl>
-                                        <p:attrNameLst>
-                                          <p:attrName>style.visibility</p:attrName>
-                                        </p:attrNameLst>
-                                      </p:cBhvr>
-                                      <p:to>
-                                        <p:strVal val="hidden"/>
-                                      </p:to>
-                                    </p:set>
-                                  </p:childTnLst>
-                                </p:cTn>
-                              </p:par>
-                              <p:par>
-                                <p:cTn id="124" presetID="10" presetClass="exit" presetSubtype="0" fill="hold" grpId="0" nodeType="withEffect">
-                                  <p:stCondLst>
-                                    <p:cond delay="0"/>
-                                  </p:stCondLst>
-                                  <p:childTnLst>
-                                    <p:animEffect transition="out" filter="fade">
-                                      <p:cBhvr>
-                                        <p:cTn id="122" dur="300"/>
-                                        <p:tgtEl>
-                                          <p:spTgt spid="29"/>
-                                        </p:tgtEl>
-                                      </p:cBhvr>
-                                    </p:animEffect>
-                                    <p:set>
-                                      <p:cBhvr>
-                                        <p:cTn id="123" dur="1" fill="hold">
-                                          <p:stCondLst>
-                                            <p:cond delay="299"/>
-                                          </p:stCondLst>
-                                        </p:cTn>
-                                        <p:tgtEl>
-                                          <p:spTgt spid="29"/>
-                                        </p:tgtEl>
-                                        <p:attrNameLst>
-                                          <p:attrName>style.visibility</p:attrName>
-                                        </p:attrNameLst>
-                                      </p:cBhvr>
-                                      <p:to>
-                                        <p:strVal val="hidden"/>
-                                      </p:to>
-                                    </p:set>
-                                  </p:childTnLst>
-                                </p:cTn>
-                              </p:par>
-                              <p:par>
-                                <p:cTn id="127" presetID="10" presetClass="exit" presetSubtype="0" fill="hold" grpId="0" nodeType="withEffect">
-                                  <p:stCondLst>
-                                    <p:cond delay="0"/>
-                                  </p:stCondLst>
-                                  <p:childTnLst>
-                                    <p:animEffect transition="out" filter="fade">
-                                      <p:cBhvr>
-                                        <p:cTn id="125" dur="300"/>
-                                        <p:tgtEl>
-                                          <p:spTgt spid="3"/>
-                                        </p:tgtEl>
-                                      </p:cBhvr>
-                                    </p:animEffect>
-                                    <p:set>
-                                      <p:cBhvr>
-                                        <p:cTn id="126" dur="1" fill="hold">
-                                          <p:stCondLst>
-                                            <p:cond delay="299"/>
-                                          </p:stCondLst>
-                                        </p:cTn>
-                                        <p:tgtEl>
-                                          <p:spTgt spid="3"/>
-                                        </p:tgtEl>
-                                        <p:attrNameLst>
-                                          <p:attrName>style.visibility</p:attrName>
-                                        </p:attrNameLst>
-                                      </p:cBhvr>
-                                      <p:to>
-                                        <p:strVal val="hidden"/>
-                                      </p:to>
-                                    </p:set>
-                                  </p:childTnLst>
-                                </p:cTn>
-                              </p:par>
-                              <p:par>
-                                <p:cTn id="130" presetID="10" presetClass="exit" presetSubtype="0" fill="hold" grpId="0" nodeType="withEffect">
-                                  <p:stCondLst>
-                                    <p:cond delay="0"/>
-                                  </p:stCondLst>
-                                  <p:childTnLst>
-                                    <p:animEffect transition="out" filter="fade">
-                                      <p:cBhvr>
-                                        <p:cTn id="128" dur="300"/>
-                                        <p:tgtEl>
-                                          <p:spTgt spid="4"/>
-                                        </p:tgtEl>
-                                      </p:cBhvr>
-                                    </p:animEffect>
-                                    <p:set>
-                                      <p:cBhvr>
-                                        <p:cTn id="129" dur="1" fill="hold">
-                                          <p:stCondLst>
-                                            <p:cond delay="299"/>
-                                          </p:stCondLst>
-                                        </p:cTn>
-                                        <p:tgtEl>
-                                          <p:spTgt spid="4"/>
-                                        </p:tgtEl>
-                                        <p:attrNameLst>
-                                          <p:attrName>style.visibility</p:attrName>
-                                        </p:attrNameLst>
-                                      </p:cBhvr>
-                                      <p:to>
-                                        <p:strVal val="hidden"/>
-                                      </p:to>
-                                    </p:set>
-                                  </p:childTnLst>
-                                </p:cTn>
-                              </p:par>
-                              <p:par>
-                                <p:cTn id="133" presetID="10" presetClass="exit" presetSubtype="0" fill="hold" grpId="0" nodeType="withEffect">
-                                  <p:stCondLst>
-                                    <p:cond delay="0"/>
-                                  </p:stCondLst>
-                                  <p:childTnLst>
-                                    <p:animEffect transition="out" filter="fade">
-                                      <p:cBhvr>
-                                        <p:cTn id="131" dur="300"/>
-                                        <p:tgtEl>
-                                          <p:spTgt spid="5"/>
-                                        </p:tgtEl>
-                                      </p:cBhvr>
-                                    </p:animEffect>
-                                    <p:set>
-                                      <p:cBhvr>
-                                        <p:cTn id="132" dur="1" fill="hold">
-                                          <p:stCondLst>
-                                            <p:cond delay="299"/>
-                                          </p:stCondLst>
-                                        </p:cTn>
-                                        <p:tgtEl>
-                                          <p:spTgt spid="5"/>
-                                        </p:tgtEl>
-                                        <p:attrNameLst>
-                                          <p:attrName>style.visibility</p:attrName>
-                                        </p:attrNameLst>
-                                      </p:cBhvr>
-                                      <p:to>
-                                        <p:strVal val="hidden"/>
-                                      </p:to>
-                                    </p:set>
-                                  </p:childTnLst>
-                                </p:cTn>
-                              </p:par>
-                              <p:par>
-                                <p:cTn id="136" presetID="10" presetClass="entr" presetSubtype="0" fill="hold" grpId="0" nodeType="withEffect">
-                                  <p:stCondLst>
-                                    <p:cond delay="400"/>
-                                  </p:stCondLst>
-                                  <p:childTnLst>
-                                    <p:set>
-                                      <p:cBhvr>
-                                        <p:cTn id="134" dur="1" fill="hold">
-                                          <p:stCondLst>
-                                            <p:cond delay="0"/>
-                                          </p:stCondLst>
-                                        </p:cTn>
-                                        <p:tgtEl>
-                                          <p:spTgt spid="42"/>
-                                        </p:tgtEl>
-                                        <p:attrNameLst>
-                                          <p:attrName>style.visibility</p:attrName>
-                                        </p:attrNameLst>
-                                      </p:cBhvr>
-                                      <p:to>
-                                        <p:strVal val="visible"/>
-                                      </p:to>
-                                    </p:set>
-                                    <p:animEffect transition="in" filter="fade">
-                                      <p:cBhvr>
-                                        <p:cTn id="135" dur="500"/>
-                                        <p:tgtEl>
-                                          <p:spTgt spid="42"/>
-                                        </p:tgtEl>
-                                      </p:cBhvr>
-                                    </p:animEffect>
-                                  </p:childTnLst>
-                                </p:cTn>
-                              </p:par>
-                              <p:par>
-                                <p:cTn id="139" presetID="10" presetClass="entr" presetSubtype="0" fill="hold" grpId="0" nodeType="withEffect">
-                                  <p:stCondLst>
-                                    <p:cond delay="400"/>
-                                  </p:stCondLst>
-                                  <p:childTnLst>
-                                    <p:set>
-                                      <p:cBhvr>
-                                        <p:cTn id="137" dur="1" fill="hold">
-                                          <p:stCondLst>
-                                            <p:cond delay="0"/>
-                                          </p:stCondLst>
-                                        </p:cTn>
-                                        <p:tgtEl>
-                                          <p:spTgt spid="43"/>
-                                        </p:tgtEl>
-                                        <p:attrNameLst>
-                                          <p:attrName>style.visibility</p:attrName>
-                                        </p:attrNameLst>
-                                      </p:cBhvr>
-                                      <p:to>
-                                        <p:strVal val="visible"/>
-                                      </p:to>
-                                    </p:set>
-                                    <p:animEffect transition="in" filter="fade">
-                                      <p:cBhvr>
-                                        <p:cTn id="138" dur="500"/>
-                                        <p:tgtEl>
-                                          <p:spTgt spid="43"/>
-                                        </p:tgtEl>
-                                      </p:cBhvr>
-                                    </p:animEffect>
-                                  </p:childTnLst>
-                                </p:cTn>
-                              </p:par>
-                              <p:par>
-                                <p:cTn id="142" presetID="10" presetClass="entr" presetSubtype="0" fill="hold" grpId="0" nodeType="withEffect">
-                                  <p:stCondLst>
-                                    <p:cond delay="400"/>
-                                  </p:stCondLst>
-                                  <p:childTnLst>
-                                    <p:set>
-                                      <p:cBhvr>
-                                        <p:cTn id="140" dur="1" fill="hold">
-                                          <p:stCondLst>
-                                            <p:cond delay="0"/>
-                                          </p:stCondLst>
-                                        </p:cTn>
-                                        <p:tgtEl>
-                                          <p:spTgt spid="44"/>
-                                        </p:tgtEl>
-                                        <p:attrNameLst>
-                                          <p:attrName>style.visibility</p:attrName>
-                                        </p:attrNameLst>
-                                      </p:cBhvr>
-                                      <p:to>
-                                        <p:strVal val="visible"/>
-                                      </p:to>
-                                    </p:set>
-                                    <p:animEffect transition="in" filter="fade">
-                                      <p:cBhvr>
-                                        <p:cTn id="141" dur="500"/>
-                                        <p:tgtEl>
-                                          <p:spTgt spid="44"/>
-                                        </p:tgtEl>
-                                      </p:cBhvr>
-                                    </p:animEffect>
-                                  </p:childTnLst>
-                                </p:cTn>
-                              </p:par>
-                              <p:par>
-                                <p:cTn id="145" presetID="10" presetClass="entr" presetSubtype="0" fill="hold" grpId="0" nodeType="withEffect">
-                                  <p:stCondLst>
-                                    <p:cond delay="450"/>
-                                  </p:stCondLst>
-                                  <p:childTnLst>
-                                    <p:set>
-                                      <p:cBhvr>
-                                        <p:cTn id="143" dur="1" fill="hold">
-                                          <p:stCondLst>
-                                            <p:cond delay="0"/>
-                                          </p:stCondLst>
-                                        </p:cTn>
-                                        <p:tgtEl>
-                                          <p:spTgt spid="45"/>
-                                        </p:tgtEl>
-                                        <p:attrNameLst>
-                                          <p:attrName>style.visibility</p:attrName>
-                                        </p:attrNameLst>
-                                      </p:cBhvr>
-                                      <p:to>
-                                        <p:strVal val="visible"/>
-                                      </p:to>
-                                    </p:set>
-                                    <p:animEffect transition="in" filter="fade">
-                                      <p:cBhvr>
-                                        <p:cTn id="144" dur="500"/>
-                                        <p:tgtEl>
-                                          <p:spTgt spid="45"/>
-                                        </p:tgtEl>
-                                      </p:cBhvr>
-                                    </p:animEffect>
-                                  </p:childTnLst>
-                                </p:cTn>
-                              </p:par>
-                            </p:childTnLst>
-                          </p:cTn>
-                        </p:par>
-                      </p:childTnLst>
-                    </p:cTn>
-                  </p:par>
-                  <p:par>
-                    <p:cTn id="146" fill="hold">
-                      <p:stCondLst>
-                        <p:cond delay="indefinite"/>
-                      </p:stCondLst>
-                      <p:childTnLst>
-                        <p:par>
-                          <p:cTn id="147" fill="hold">
-                            <p:stCondLst>
-                              <p:cond delay="0"/>
-                            </p:stCondLst>
-                            <p:childTnLst>
-                              <p:par>
-                                <p:cTn id="150" presetID="10" presetClass="entr" presetSubtype="0" fill="hold" grpId="0" nodeType="clickEffect">
-                                  <p:stCondLst>
-                                    <p:cond delay="0"/>
-                                  </p:stCondLst>
-                                  <p:childTnLst>
-                                    <p:set>
-                                      <p:cBhvr>
-                                        <p:cTn id="148" dur="1" fill="hold">
-                                          <p:stCondLst>
-                                            <p:cond delay="0"/>
-                                          </p:stCondLst>
-                                        </p:cTn>
-                                        <p:tgtEl>
-                                          <p:spTgt spid="46"/>
-                                        </p:tgtEl>
-                                        <p:attrNameLst>
-                                          <p:attrName>style.visibility</p:attrName>
-                                        </p:attrNameLst>
-                                      </p:cBhvr>
-                                      <p:to>
-                                        <p:strVal val="visible"/>
-                                      </p:to>
-                                    </p:set>
-                                    <p:animEffect transition="in" filter="fade">
-                                      <p:cBhvr>
-                                        <p:cTn id="149" dur="500"/>
-                                        <p:tgtEl>
-                                          <p:spTgt spid="46"/>
-                                        </p:tgtEl>
-                                      </p:cBhvr>
-                                    </p:animEffect>
-                                  </p:childTnLst>
-                                </p:cTn>
-                              </p:par>
-                            </p:childTnLst>
-                          </p:cTn>
-                        </p:par>
-                      </p:childTnLst>
-                    </p:cTn>
-                  </p:par>
-                  <p:par>
-                    <p:cTn id="151" fill="hold">
-                      <p:stCondLst>
-                        <p:cond delay="indefinite"/>
-                      </p:stCondLst>
-                      <p:childTnLst>
-                        <p:par>
-                          <p:cTn id="152" fill="hold">
-                            <p:stCondLst>
-                              <p:cond delay="0"/>
-                            </p:stCondLst>
-                            <p:childTnLst>
-                              <p:par>
-                                <p:cTn id="155" presetID="10" presetClass="entr" presetSubtype="0" fill="hold" grpId="0" nodeType="clickEffect">
-                                  <p:stCondLst>
-                                    <p:cond delay="0"/>
-                                  </p:stCondLst>
-                                  <p:childTnLst>
-                                    <p:set>
-                                      <p:cBhvr>
-                                        <p:cTn id="153" dur="1" fill="hold">
-                                          <p:stCondLst>
-                                            <p:cond delay="0"/>
-                                          </p:stCondLst>
-                                        </p:cTn>
-                                        <p:tgtEl>
-                                          <p:spTgt spid="47"/>
-                                        </p:tgtEl>
-                                        <p:attrNameLst>
-                                          <p:attrName>style.visibility</p:attrName>
-                                        </p:attrNameLst>
-                                      </p:cBhvr>
-                                      <p:to>
-                                        <p:strVal val="visible"/>
-                                      </p:to>
-                                    </p:set>
-                                    <p:animEffect transition="in" filter="fade">
-                                      <p:cBhvr>
-                                        <p:cTn id="154" dur="500"/>
-                                        <p:tgtEl>
-                                          <p:spTgt spid="47"/>
-                                        </p:tgtEl>
-                                      </p:cBhvr>
-                                    </p:animEffect>
-                                  </p:childTnLst>
-                                </p:cTn>
-                              </p:par>
-                            </p:childTnLst>
-                          </p:cTn>
-                        </p:par>
-                      </p:childTnLst>
-                    </p:cTn>
-                  </p:par>
-                  <p:par>
-                    <p:cTn id="156" fill="hold">
-                      <p:stCondLst>
-                        <p:cond delay="indefinite"/>
-                      </p:stCondLst>
-                      <p:childTnLst>
-                        <p:par>
-                          <p:cTn id="157" fill="hold">
-                            <p:stCondLst>
-                              <p:cond delay="0"/>
-                            </p:stCondLst>
-                            <p:childTnLst>
-                              <p:par>
-                                <p:cTn id="160" presetID="10" presetClass="entr" presetSubtype="0" fill="hold" grpId="0" nodeType="clickEffect">
-                                  <p:stCondLst>
-                                    <p:cond delay="0"/>
-                                  </p:stCondLst>
-                                  <p:childTnLst>
-                                    <p:set>
-                                      <p:cBhvr>
-                                        <p:cTn id="158" dur="1" fill="hold">
-                                          <p:stCondLst>
-                                            <p:cond delay="0"/>
-                                          </p:stCondLst>
-                                        </p:cTn>
-                                        <p:tgtEl>
-                                          <p:spTgt spid="48"/>
-                                        </p:tgtEl>
-                                        <p:attrNameLst>
-                                          <p:attrName>style.visibility</p:attrName>
-                                        </p:attrNameLst>
-                                      </p:cBhvr>
-                                      <p:to>
-                                        <p:strVal val="visible"/>
-                                      </p:to>
-                                    </p:set>
-                                    <p:animEffect transition="in" filter="fade">
-                                      <p:cBhvr>
-                                        <p:cTn id="159" dur="500"/>
-                                        <p:tgtEl>
-                                          <p:spTgt spid="48"/>
-                                        </p:tgtEl>
-                                      </p:cBhvr>
-                                    </p:animEffect>
-                                  </p:childTnLst>
-                                </p:cTn>
-                              </p:par>
-                            </p:childTnLst>
-                          </p:cTn>
-                        </p:par>
-                      </p:childTnLst>
-                    </p:cTn>
-                  </p:par>
                 </p:childTnLst>
               </p:cTn>
               <p:prevCondLst>
@@ -5136,16 +3538,6 @@
       <p:bldP spid="40" grpId="0" animBg="1"/>
       <p:bldP spid="41" grpId="0" animBg="1"/>
       <p:bldP spid="29" grpId="0" animBg="1"/>
-      <p:bldP spid="3" grpId="0"/>
-      <p:bldP spid="4" grpId="0"/>
-      <p:bldP spid="5" grpId="0"/>
-      <p:bldP spid="42" grpId="0"/>
-      <p:bldP spid="43" grpId="0"/>
-      <p:bldP spid="44" grpId="0"/>
-      <p:bldP spid="45" grpId="0" animBg="1"/>
-      <p:bldP spid="46" grpId="0" animBg="1"/>
-      <p:bldP spid="47" grpId="0" animBg="1"/>
-      <p:bldP spid="48" grpId="0" animBg="1"/>
     </p:bldLst>
   </p:timing>
 </p:sld>

</xml_diff>

<commit_message>
Friction slide: add the medical director to the flow map
Co-Authored-By: Claude Sonnet 5.5 <noreply@anthropic.com>
</commit_message>
<xml_diff>
--- a/deck/journey/Friction_Click_Through.pptx
+++ b/deck/journey/Friction_Click_Through.pptx
@@ -1046,7 +1046,7 @@
         <p:spPr>
           <a:xfrm>
             <a:off x="457200" y="1783080"/>
-            <a:ext cx="1828800" cy="731520"/>
+            <a:ext cx="1664208" cy="731520"/>
           </a:xfrm>
           <a:prstGeom prst="roundRect">
             <a:avLst>
@@ -1063,14 +1063,14 @@
           </a:ln>
         </p:spPr>
         <p:txBody>
-          <a:bodyPr wrap="square" lIns="658368" tIns="36576" rIns="73152" bIns="36576" rtlCol="0" anchor="ctr"/>
+          <a:bodyPr wrap="square" lIns="566928" tIns="36576" rIns="54864" bIns="36576" rtlCol="0" anchor="ctr"/>
           <a:lstStyle/>
           <a:p>
             <a:pPr algn="l" indent="0" marL="0">
               <a:buNone/>
             </a:pPr>
             <a:r>
-              <a:rPr lang="en-US" sz="1200" b="1" dirty="0">
+              <a:rPr lang="en-US" sz="1100" b="1" dirty="0">
                 <a:solidFill>
                   <a:srgbClr val="16211E"/>
                 </a:solidFill>
@@ -1080,14 +1080,14 @@
               </a:rPr>
               <a:t>Surgeon's office</a:t>
             </a:r>
-            <a:endParaRPr lang="en-US" sz="1200" dirty="0"/>
+            <a:endParaRPr lang="en-US" sz="1100" dirty="0"/>
           </a:p>
           <a:p>
             <a:pPr algn="l" indent="0" marL="0">
               <a:buNone/>
             </a:pPr>
             <a:r>
-              <a:rPr lang="en-US" sz="950" dirty="0">
+              <a:rPr lang="en-US" sz="900" dirty="0">
                 <a:solidFill>
                   <a:srgbClr val="5C6B66"/>
                 </a:solidFill>
@@ -1097,7 +1097,7 @@
               </a:rPr>
               <a:t>Sends the packet</a:t>
             </a:r>
-            <a:endParaRPr lang="en-US" sz="1200" dirty="0"/>
+            <a:endParaRPr lang="en-US" sz="1100" dirty="0"/>
           </a:p>
         </p:txBody>
       </p:sp>
@@ -1117,8 +1117,8 @@
         </p:blipFill>
         <p:spPr>
           <a:xfrm>
-            <a:off x="539496" y="1892808"/>
-            <a:ext cx="512064" cy="512064"/>
+            <a:off x="530352" y="1938528"/>
+            <a:ext cx="420624" cy="420624"/>
           </a:xfrm>
           <a:prstGeom prst="rect">
             <a:avLst/>
@@ -1133,8 +1133,8 @@
         </p:nvSpPr>
         <p:spPr>
           <a:xfrm>
-            <a:off x="2816352" y="1783080"/>
-            <a:ext cx="1828800" cy="731520"/>
+            <a:off x="2377440" y="1783080"/>
+            <a:ext cx="1664208" cy="731520"/>
           </a:xfrm>
           <a:prstGeom prst="roundRect">
             <a:avLst>
@@ -1151,14 +1151,14 @@
           </a:ln>
         </p:spPr>
         <p:txBody>
-          <a:bodyPr wrap="square" lIns="658368" tIns="36576" rIns="73152" bIns="36576" rtlCol="0" anchor="ctr"/>
+          <a:bodyPr wrap="square" lIns="566928" tIns="36576" rIns="54864" bIns="36576" rtlCol="0" anchor="ctr"/>
           <a:lstStyle/>
           <a:p>
             <a:pPr algn="l" indent="0" marL="0">
               <a:buNone/>
             </a:pPr>
             <a:r>
-              <a:rPr lang="en-US" sz="1200" b="1" dirty="0">
+              <a:rPr lang="en-US" sz="1100" b="1" dirty="0">
                 <a:solidFill>
                   <a:srgbClr val="16211E"/>
                 </a:solidFill>
@@ -1168,14 +1168,14 @@
               </a:rPr>
               <a:t>Intake</a:t>
             </a:r>
-            <a:endParaRPr lang="en-US" sz="1200" dirty="0"/>
+            <a:endParaRPr lang="en-US" sz="1100" dirty="0"/>
           </a:p>
           <a:p>
             <a:pPr algn="l" indent="0" marL="0">
               <a:buNone/>
             </a:pPr>
             <a:r>
-              <a:rPr lang="en-US" sz="950" dirty="0">
+              <a:rPr lang="en-US" sz="900" dirty="0">
                 <a:solidFill>
                   <a:srgbClr val="5C6B66"/>
                 </a:solidFill>
@@ -1185,7 +1185,7 @@
               </a:rPr>
               <a:t>Checks it in</a:t>
             </a:r>
-            <a:endParaRPr lang="en-US" sz="1200" dirty="0"/>
+            <a:endParaRPr lang="en-US" sz="1100" dirty="0"/>
           </a:p>
         </p:txBody>
       </p:sp>
@@ -1205,8 +1205,8 @@
         </p:blipFill>
         <p:spPr>
           <a:xfrm>
-            <a:off x="2898648" y="1892808"/>
-            <a:ext cx="512064" cy="512064"/>
+            <a:off x="2450592" y="1938528"/>
+            <a:ext cx="420624" cy="420624"/>
           </a:xfrm>
           <a:prstGeom prst="rect">
             <a:avLst/>
@@ -1221,8 +1221,8 @@
         </p:nvSpPr>
         <p:spPr>
           <a:xfrm>
-            <a:off x="5175504" y="1783080"/>
-            <a:ext cx="1828800" cy="731520"/>
+            <a:off x="4297680" y="1783080"/>
+            <a:ext cx="1664208" cy="731520"/>
           </a:xfrm>
           <a:prstGeom prst="roundRect">
             <a:avLst>
@@ -1239,14 +1239,14 @@
           </a:ln>
         </p:spPr>
         <p:txBody>
-          <a:bodyPr wrap="square" lIns="658368" tIns="36576" rIns="73152" bIns="36576" rtlCol="0" anchor="ctr"/>
+          <a:bodyPr wrap="square" lIns="566928" tIns="36576" rIns="54864" bIns="36576" rtlCol="0" anchor="ctr"/>
           <a:lstStyle/>
           <a:p>
             <a:pPr algn="l" indent="0" marL="0">
               <a:buNone/>
             </a:pPr>
             <a:r>
-              <a:rPr lang="en-US" sz="1200" b="1" dirty="0">
+              <a:rPr lang="en-US" sz="1100" b="1" dirty="0">
                 <a:solidFill>
                   <a:srgbClr val="16211E"/>
                 </a:solidFill>
@@ -1256,14 +1256,14 @@
               </a:rPr>
               <a:t>UM nurse</a:t>
             </a:r>
-            <a:endParaRPr lang="en-US" sz="1200" dirty="0"/>
+            <a:endParaRPr lang="en-US" sz="1100" dirty="0"/>
           </a:p>
           <a:p>
             <a:pPr algn="l" indent="0" marL="0">
               <a:buNone/>
             </a:pPr>
             <a:r>
-              <a:rPr lang="en-US" sz="950" dirty="0">
+              <a:rPr lang="en-US" sz="900" dirty="0">
                 <a:solidFill>
                   <a:srgbClr val="5C6B66"/>
                 </a:solidFill>
@@ -1273,7 +1273,7 @@
               </a:rPr>
               <a:t>Reads the packet</a:t>
             </a:r>
-            <a:endParaRPr lang="en-US" sz="1200" dirty="0"/>
+            <a:endParaRPr lang="en-US" sz="1100" dirty="0"/>
           </a:p>
         </p:txBody>
       </p:sp>
@@ -1293,8 +1293,8 @@
         </p:blipFill>
         <p:spPr>
           <a:xfrm>
-            <a:off x="5257800" y="1892808"/>
-            <a:ext cx="512064" cy="512064"/>
+            <a:off x="4370832" y="1938528"/>
+            <a:ext cx="420624" cy="420624"/>
           </a:xfrm>
           <a:prstGeom prst="rect">
             <a:avLst/>
@@ -1309,8 +1309,8 @@
         </p:nvSpPr>
         <p:spPr>
           <a:xfrm>
-            <a:off x="7534656" y="1783080"/>
-            <a:ext cx="1828800" cy="731520"/>
+            <a:off x="6217920" y="1783080"/>
+            <a:ext cx="1664208" cy="731520"/>
           </a:xfrm>
           <a:prstGeom prst="roundRect">
             <a:avLst>
@@ -1327,14 +1327,14 @@
           </a:ln>
         </p:spPr>
         <p:txBody>
-          <a:bodyPr wrap="square" lIns="91440" tIns="36576" rIns="91440" bIns="36576" rtlCol="0" anchor="ctr"/>
+          <a:bodyPr wrap="square" lIns="73152" tIns="36576" rIns="73152" bIns="36576" rtlCol="0" anchor="ctr"/>
           <a:lstStyle/>
           <a:p>
             <a:pPr algn="ctr" indent="0" marL="0">
               <a:buNone/>
             </a:pPr>
             <a:r>
-              <a:rPr lang="en-US" sz="1200" b="1" dirty="0">
+              <a:rPr lang="en-US" sz="1100" b="1" dirty="0">
                 <a:solidFill>
                   <a:srgbClr val="16211E"/>
                 </a:solidFill>
@@ -1344,14 +1344,14 @@
               </a:rPr>
               <a:t>Decision</a:t>
             </a:r>
-            <a:endParaRPr lang="en-US" sz="1200" dirty="0"/>
+            <a:endParaRPr lang="en-US" sz="1100" dirty="0"/>
           </a:p>
           <a:p>
             <a:pPr algn="ctr" indent="0" marL="0">
               <a:buNone/>
             </a:pPr>
             <a:r>
-              <a:rPr lang="en-US" sz="950" dirty="0">
+              <a:rPr lang="en-US" sz="900" dirty="0">
                 <a:solidFill>
                   <a:srgbClr val="5C6B66"/>
                 </a:solidFill>
@@ -1361,7 +1361,7 @@
               </a:rPr>
               <a:t>Approve, pend, escalate</a:t>
             </a:r>
-            <a:endParaRPr lang="en-US" sz="1200" dirty="0"/>
+            <a:endParaRPr lang="en-US" sz="1100" dirty="0"/>
           </a:p>
         </p:txBody>
       </p:sp>
@@ -1373,8 +1373,8 @@
         </p:nvSpPr>
         <p:spPr>
           <a:xfrm>
-            <a:off x="9902952" y="1783080"/>
-            <a:ext cx="1828800" cy="731520"/>
+            <a:off x="8138160" y="1783080"/>
+            <a:ext cx="1664208" cy="731520"/>
           </a:xfrm>
           <a:prstGeom prst="roundRect">
             <a:avLst>
@@ -1382,23 +1382,23 @@
             </a:avLst>
           </a:prstGeom>
           <a:solidFill>
-            <a:srgbClr val="FFFFFF"/>
+            <a:srgbClr val="EBE2F8"/>
           </a:solidFill>
           <a:ln w="12700">
             <a:solidFill>
-              <a:srgbClr val="CBD5D1"/>
+              <a:srgbClr val="5F3AA8"/>
             </a:solidFill>
           </a:ln>
         </p:spPr>
         <p:txBody>
-          <a:bodyPr wrap="square" lIns="658368" tIns="36576" rIns="73152" bIns="36576" rtlCol="0" anchor="ctr"/>
+          <a:bodyPr wrap="square" lIns="566928" tIns="36576" rIns="54864" bIns="36576" rtlCol="0" anchor="ctr"/>
           <a:lstStyle/>
           <a:p>
             <a:pPr algn="l" indent="0" marL="0">
               <a:buNone/>
             </a:pPr>
             <a:r>
-              <a:rPr lang="en-US" sz="1200" b="1" dirty="0">
+              <a:rPr lang="en-US" sz="1100" b="1" dirty="0">
                 <a:solidFill>
                   <a:srgbClr val="16211E"/>
                 </a:solidFill>
@@ -1406,16 +1406,16 @@
                 <a:ea typeface="Calibri" pitchFamily="34" charset="-122"/>
                 <a:cs typeface="Calibri" pitchFamily="34" charset="-120"/>
               </a:rPr>
-              <a:t>The member</a:t>
-            </a:r>
-            <a:endParaRPr lang="en-US" sz="1200" dirty="0"/>
+              <a:t>Medical director</a:t>
+            </a:r>
+            <a:endParaRPr lang="en-US" sz="1100" dirty="0"/>
           </a:p>
           <a:p>
             <a:pPr algn="l" indent="0" marL="0">
               <a:buNone/>
             </a:pPr>
             <a:r>
-              <a:rPr lang="en-US" sz="950" dirty="0">
+              <a:rPr lang="en-US" sz="900" dirty="0">
                 <a:solidFill>
                   <a:srgbClr val="5C6B66"/>
                 </a:solidFill>
@@ -1423,15 +1423,15 @@
                 <a:ea typeface="Calibri" pitchFamily="34" charset="-122"/>
                 <a:cs typeface="Calibri" pitchFamily="34" charset="-120"/>
               </a:rPr>
-              <a:t>Waits for the answer</a:t>
-            </a:r>
-            <a:endParaRPr lang="en-US" sz="1200" dirty="0"/>
+              <a:t>Only when escalated</a:t>
+            </a:r>
+            <a:endParaRPr lang="en-US" sz="1100" dirty="0"/>
           </a:p>
         </p:txBody>
       </p:sp>
       <p:pic>
         <p:nvPicPr>
-          <p:cNvPr id="14" name="AvM" descr="preencoded.png">    </p:cNvPr>
+          <p:cNvPr id="14" name="AvMD" descr="preencoded.png">    </p:cNvPr>
           <p:cNvPicPr>
             <a:picLocks noChangeAspect="1"/>
           </p:cNvPicPr>
@@ -1445,8 +1445,8 @@
         </p:blipFill>
         <p:spPr>
           <a:xfrm>
-            <a:off x="9985248" y="1892808"/>
-            <a:ext cx="512064" cy="512064"/>
+            <a:off x="8211312" y="1938528"/>
+            <a:ext cx="420624" cy="420624"/>
           </a:xfrm>
           <a:prstGeom prst="rect">
             <a:avLst/>
@@ -1455,14 +1455,102 @@
       </p:pic>
       <p:sp>
         <p:nvSpPr>
-          <p:cNvPr id="15" name="A12"/>
+          <p:cNvPr id="15" name="N6"/>
           <p:cNvSpPr/>
           <p:nvPr/>
         </p:nvSpPr>
         <p:spPr>
           <a:xfrm>
-            <a:off x="2322576" y="2148840"/>
-            <a:ext cx="457200" cy="0"/>
+            <a:off x="10058400" y="1783080"/>
+            <a:ext cx="1664208" cy="731520"/>
+          </a:xfrm>
+          <a:prstGeom prst="roundRect">
+            <a:avLst>
+              <a:gd name="adj" fmla="val 10000"/>
+            </a:avLst>
+          </a:prstGeom>
+          <a:solidFill>
+            <a:srgbClr val="FFFFFF"/>
+          </a:solidFill>
+          <a:ln w="12700">
+            <a:solidFill>
+              <a:srgbClr val="CBD5D1"/>
+            </a:solidFill>
+          </a:ln>
+        </p:spPr>
+        <p:txBody>
+          <a:bodyPr wrap="square" lIns="566928" tIns="36576" rIns="54864" bIns="36576" rtlCol="0" anchor="ctr"/>
+          <a:lstStyle/>
+          <a:p>
+            <a:pPr algn="l" indent="0" marL="0">
+              <a:buNone/>
+            </a:pPr>
+            <a:r>
+              <a:rPr lang="en-US" sz="1100" b="1" dirty="0">
+                <a:solidFill>
+                  <a:srgbClr val="16211E"/>
+                </a:solidFill>
+                <a:latin typeface="Calibri" pitchFamily="34" charset="0"/>
+                <a:ea typeface="Calibri" pitchFamily="34" charset="-122"/>
+                <a:cs typeface="Calibri" pitchFamily="34" charset="-120"/>
+              </a:rPr>
+              <a:t>The member</a:t>
+            </a:r>
+            <a:endParaRPr lang="en-US" sz="1100" dirty="0"/>
+          </a:p>
+          <a:p>
+            <a:pPr algn="l" indent="0" marL="0">
+              <a:buNone/>
+            </a:pPr>
+            <a:r>
+              <a:rPr lang="en-US" sz="900" dirty="0">
+                <a:solidFill>
+                  <a:srgbClr val="5C6B66"/>
+                </a:solidFill>
+                <a:latin typeface="Calibri" pitchFamily="34" charset="0"/>
+                <a:ea typeface="Calibri" pitchFamily="34" charset="-122"/>
+                <a:cs typeface="Calibri" pitchFamily="34" charset="-120"/>
+              </a:rPr>
+              <a:t>Waits for the answer</a:t>
+            </a:r>
+            <a:endParaRPr lang="en-US" sz="1100" dirty="0"/>
+          </a:p>
+        </p:txBody>
+      </p:sp>
+      <p:pic>
+        <p:nvPicPr>
+          <p:cNvPr id="16" name="AvM" descr="preencoded.png">    </p:cNvPr>
+          <p:cNvPicPr>
+            <a:picLocks noChangeAspect="1"/>
+          </p:cNvPicPr>
+          <p:nvPr/>
+        </p:nvPicPr>
+        <p:blipFill>
+          <a:blip r:embed="rId5"/>
+          <a:stretch>
+            <a:fillRect/>
+          </a:stretch>
+        </p:blipFill>
+        <p:spPr>
+          <a:xfrm>
+            <a:off x="10131552" y="1938528"/>
+            <a:ext cx="420624" cy="420624"/>
+          </a:xfrm>
+          <a:prstGeom prst="rect">
+            <a:avLst/>
+          </a:prstGeom>
+        </p:spPr>
+      </p:pic>
+      <p:sp>
+        <p:nvSpPr>
+          <p:cNvPr id="17" name="A12"/>
+          <p:cNvSpPr/>
+          <p:nvPr/>
+        </p:nvSpPr>
+        <p:spPr>
+          <a:xfrm>
+            <a:off x="2148840" y="2148840"/>
+            <a:ext cx="201168" cy="0"/>
           </a:xfrm>
           <a:prstGeom prst="line">
             <a:avLst/>
@@ -1479,14 +1567,14 @@
       </p:sp>
       <p:sp>
         <p:nvSpPr>
-          <p:cNvPr id="16" name="A23"/>
+          <p:cNvPr id="18" name="A23"/>
           <p:cNvSpPr/>
           <p:nvPr/>
         </p:nvSpPr>
         <p:spPr>
           <a:xfrm>
-            <a:off x="4681728" y="2148840"/>
-            <a:ext cx="457200" cy="0"/>
+            <a:off x="4069080" y="2148840"/>
+            <a:ext cx="201168" cy="0"/>
           </a:xfrm>
           <a:prstGeom prst="line">
             <a:avLst/>
@@ -1503,14 +1591,14 @@
       </p:sp>
       <p:sp>
         <p:nvSpPr>
-          <p:cNvPr id="17" name="A34"/>
+          <p:cNvPr id="19" name="A34"/>
           <p:cNvSpPr/>
           <p:nvPr/>
         </p:nvSpPr>
         <p:spPr>
           <a:xfrm>
-            <a:off x="7040880" y="2148840"/>
-            <a:ext cx="457200" cy="0"/>
+            <a:off x="5989320" y="2148840"/>
+            <a:ext cx="201168" cy="0"/>
           </a:xfrm>
           <a:prstGeom prst="line">
             <a:avLst/>
@@ -1527,14 +1615,38 @@
       </p:sp>
       <p:sp>
         <p:nvSpPr>
-          <p:cNvPr id="18" name="A45"/>
+          <p:cNvPr id="20" name="A45"/>
           <p:cNvSpPr/>
           <p:nvPr/>
         </p:nvSpPr>
         <p:spPr>
           <a:xfrm>
-            <a:off x="9400032" y="2148840"/>
-            <a:ext cx="457200" cy="0"/>
+            <a:off x="7909560" y="2148840"/>
+            <a:ext cx="201168" cy="0"/>
+          </a:xfrm>
+          <a:prstGeom prst="line">
+            <a:avLst/>
+          </a:prstGeom>
+          <a:noFill/>
+          <a:ln w="22225">
+            <a:solidFill>
+              <a:srgbClr val="5F3AA8"/>
+            </a:solidFill>
+            <a:prstDash val="solid"/>
+            <a:tailEnd type="triangle"/>
+          </a:ln>
+        </p:spPr>
+      </p:sp>
+      <p:sp>
+        <p:nvSpPr>
+          <p:cNvPr id="21" name="A56"/>
+          <p:cNvSpPr/>
+          <p:nvPr/>
+        </p:nvSpPr>
+        <p:spPr>
+          <a:xfrm>
+            <a:off x="9829800" y="2148840"/>
+            <a:ext cx="201168" cy="0"/>
           </a:xfrm>
           <a:prstGeom prst="line">
             <a:avLst/>
@@ -1551,14 +1663,14 @@
       </p:sp>
       <p:sp>
         <p:nvSpPr>
-          <p:cNvPr id="19" name="LblFax"/>
+          <p:cNvPr id="22" name="LblFax"/>
           <p:cNvSpPr txBox="1"/>
           <p:nvPr/>
         </p:nvSpPr>
         <p:spPr>
           <a:xfrm>
-            <a:off x="2286000" y="1892808"/>
-            <a:ext cx="530352" cy="182880"/>
+            <a:off x="2084832" y="1874520"/>
+            <a:ext cx="329184" cy="182880"/>
           </a:xfrm>
           <a:prstGeom prst="rect">
             <a:avLst/>
@@ -1574,7 +1686,7 @@
               <a:buNone/>
             </a:pPr>
             <a:r>
-              <a:rPr lang="en-US" sz="800" b="1" spc="200" kern="0" dirty="0">
+              <a:rPr lang="en-US" sz="750" b="1" dirty="0">
                 <a:solidFill>
                   <a:srgbClr val="B8452F"/>
                 </a:solidFill>
@@ -1584,19 +1696,19 @@
               </a:rPr>
               <a:t>FAX</a:t>
             </a:r>
-            <a:endParaRPr lang="en-US" sz="800" dirty="0"/>
+            <a:endParaRPr lang="en-US" sz="750" dirty="0"/>
           </a:p>
         </p:txBody>
       </p:sp>
       <p:sp>
         <p:nvSpPr>
-          <p:cNvPr id="20" name="L1"/>
+          <p:cNvPr id="23" name="L1"/>
           <p:cNvSpPr/>
           <p:nvPr/>
         </p:nvSpPr>
         <p:spPr>
           <a:xfrm>
-            <a:off x="8449056" y="2514600"/>
+            <a:off x="7050024" y="2514600"/>
             <a:ext cx="0" cy="274320"/>
           </a:xfrm>
           <a:prstGeom prst="line">
@@ -1613,14 +1725,14 @@
       </p:sp>
       <p:sp>
         <p:nvSpPr>
-          <p:cNvPr id="21" name="L2"/>
+          <p:cNvPr id="24" name="L2"/>
           <p:cNvSpPr/>
           <p:nvPr/>
         </p:nvSpPr>
         <p:spPr>
           <a:xfrm>
-            <a:off x="1371600" y="2788920"/>
-            <a:ext cx="7077456" cy="0"/>
+            <a:off x="1289304" y="2788920"/>
+            <a:ext cx="5760720" cy="0"/>
           </a:xfrm>
           <a:prstGeom prst="line">
             <a:avLst/>
@@ -1636,13 +1748,13 @@
       </p:sp>
       <p:sp>
         <p:nvSpPr>
-          <p:cNvPr id="22" name="L3"/>
+          <p:cNvPr id="25" name="L3"/>
           <p:cNvSpPr/>
           <p:nvPr/>
         </p:nvSpPr>
         <p:spPr>
           <a:xfrm flipV="1">
-            <a:off x="1371600" y="2514600"/>
+            <a:off x="1289304" y="2514600"/>
             <a:ext cx="0" cy="274320"/>
           </a:xfrm>
           <a:prstGeom prst="line">
@@ -1660,14 +1772,14 @@
       </p:sp>
       <p:sp>
         <p:nvSpPr>
-          <p:cNvPr id="23" name="LblLoop"/>
+          <p:cNvPr id="26" name="LblLoop"/>
           <p:cNvSpPr txBox="1"/>
           <p:nvPr/>
         </p:nvSpPr>
         <p:spPr>
           <a:xfrm>
-            <a:off x="2926080" y="2569464"/>
-            <a:ext cx="3657600" cy="201168"/>
+            <a:off x="2286000" y="2569464"/>
+            <a:ext cx="3840480" cy="201168"/>
           </a:xfrm>
           <a:prstGeom prst="rect">
             <a:avLst/>
@@ -1699,13 +1811,13 @@
       </p:sp>
       <p:sp>
         <p:nvSpPr>
-          <p:cNvPr id="24" name="Pin1"/>
+          <p:cNvPr id="27" name="Pin1"/>
           <p:cNvSpPr/>
           <p:nvPr/>
         </p:nvSpPr>
         <p:spPr>
           <a:xfrm>
-            <a:off x="5532120" y="1453896"/>
+            <a:off x="4562856" y="1453896"/>
             <a:ext cx="292608" cy="292608"/>
           </a:xfrm>
           <a:prstGeom prst="roundRect">
@@ -1746,13 +1858,13 @@
       </p:sp>
       <p:sp>
         <p:nvSpPr>
-          <p:cNvPr id="25" name="Pin3"/>
+          <p:cNvPr id="28" name="Pin3"/>
           <p:cNvSpPr/>
           <p:nvPr/>
         </p:nvSpPr>
         <p:spPr>
           <a:xfrm>
-            <a:off x="6355080" y="1453896"/>
+            <a:off x="5404104" y="1453896"/>
             <a:ext cx="292608" cy="292608"/>
           </a:xfrm>
           <a:prstGeom prst="roundRect">
@@ -1793,13 +1905,13 @@
       </p:sp>
       <p:sp>
         <p:nvSpPr>
-          <p:cNvPr id="26" name="Pin2"/>
+          <p:cNvPr id="29" name="Pin2"/>
           <p:cNvSpPr/>
           <p:nvPr/>
         </p:nvSpPr>
         <p:spPr>
           <a:xfrm>
-            <a:off x="2404872" y="2313432"/>
+            <a:off x="2103120" y="1453896"/>
             <a:ext cx="292608" cy="292608"/>
           </a:xfrm>
           <a:prstGeom prst="roundRect">
@@ -1840,13 +1952,13 @@
       </p:sp>
       <p:sp>
         <p:nvSpPr>
-          <p:cNvPr id="27" name="Pin4"/>
+          <p:cNvPr id="30" name="Pin4"/>
           <p:cNvSpPr/>
           <p:nvPr/>
         </p:nvSpPr>
         <p:spPr>
           <a:xfrm>
-            <a:off x="8302752" y="1453896"/>
+            <a:off x="7863840" y="1453896"/>
             <a:ext cx="292608" cy="292608"/>
           </a:xfrm>
           <a:prstGeom prst="roundRect">
@@ -1887,13 +1999,13 @@
       </p:sp>
       <p:sp>
         <p:nvSpPr>
-          <p:cNvPr id="28" name="Pin5"/>
+          <p:cNvPr id="31" name="Pin5"/>
           <p:cNvSpPr/>
           <p:nvPr/>
         </p:nvSpPr>
         <p:spPr>
           <a:xfrm>
-            <a:off x="2139696" y="2642616"/>
+            <a:off x="2057400" y="2642616"/>
             <a:ext cx="292608" cy="292608"/>
           </a:xfrm>
           <a:prstGeom prst="roundRect">
@@ -1934,13 +2046,13 @@
       </p:sp>
       <p:sp>
         <p:nvSpPr>
-          <p:cNvPr id="29" name="Pin6"/>
+          <p:cNvPr id="32" name="Pin6"/>
           <p:cNvSpPr/>
           <p:nvPr/>
         </p:nvSpPr>
         <p:spPr>
           <a:xfrm>
-            <a:off x="10671048" y="1453896"/>
+            <a:off x="10744200" y="1453896"/>
             <a:ext cx="292608" cy="292608"/>
           </a:xfrm>
           <a:prstGeom prst="roundRect">
@@ -1981,7 +2093,7 @@
       </p:sp>
       <p:sp>
         <p:nvSpPr>
-          <p:cNvPr id="30" name="Card1"/>
+          <p:cNvPr id="33" name="Card1"/>
           <p:cNvSpPr/>
           <p:nvPr/>
         </p:nvSpPr>
@@ -2062,7 +2174,7 @@
       </p:sp>
       <p:sp>
         <p:nvSpPr>
-          <p:cNvPr id="31" name="Num1"/>
+          <p:cNvPr id="34" name="Num1"/>
           <p:cNvSpPr/>
           <p:nvPr/>
         </p:nvSpPr>
@@ -2109,7 +2221,7 @@
       </p:sp>
       <p:sp>
         <p:nvSpPr>
-          <p:cNvPr id="32" name="Card2"/>
+          <p:cNvPr id="35" name="Card2"/>
           <p:cNvSpPr/>
           <p:nvPr/>
         </p:nvSpPr>
@@ -2190,7 +2302,7 @@
       </p:sp>
       <p:sp>
         <p:nvSpPr>
-          <p:cNvPr id="33" name="Num2"/>
+          <p:cNvPr id="36" name="Num2"/>
           <p:cNvSpPr/>
           <p:nvPr/>
         </p:nvSpPr>
@@ -2237,7 +2349,7 @@
       </p:sp>
       <p:sp>
         <p:nvSpPr>
-          <p:cNvPr id="34" name="Card3"/>
+          <p:cNvPr id="37" name="Card3"/>
           <p:cNvSpPr/>
           <p:nvPr/>
         </p:nvSpPr>
@@ -2318,7 +2430,7 @@
       </p:sp>
       <p:sp>
         <p:nvSpPr>
-          <p:cNvPr id="35" name="Num3"/>
+          <p:cNvPr id="38" name="Num3"/>
           <p:cNvSpPr/>
           <p:nvPr/>
         </p:nvSpPr>
@@ -2365,7 +2477,7 @@
       </p:sp>
       <p:sp>
         <p:nvSpPr>
-          <p:cNvPr id="36" name="Card4"/>
+          <p:cNvPr id="39" name="Card4"/>
           <p:cNvSpPr/>
           <p:nvPr/>
         </p:nvSpPr>
@@ -2421,7 +2533,7 @@
                 <a:ea typeface="Calibri" pitchFamily="34" charset="-122"/>
                 <a:cs typeface="Calibri" pitchFamily="34" charset="-120"/>
               </a:rPr>
-              <a:t>Two reviewers can read the same packet and reach different decisions.</a:t>
+              <a:t>Two reviewers, nurse or physician, can read the same packet and reach different decisions.</a:t>
             </a:r>
             <a:endParaRPr lang="en-US" sz="1500" dirty="0"/>
           </a:p>
@@ -2446,7 +2558,7 @@
       </p:sp>
       <p:sp>
         <p:nvSpPr>
-          <p:cNvPr id="37" name="Num4"/>
+          <p:cNvPr id="40" name="Num4"/>
           <p:cNvSpPr/>
           <p:nvPr/>
         </p:nvSpPr>
@@ -2493,7 +2605,7 @@
       </p:sp>
       <p:sp>
         <p:nvSpPr>
-          <p:cNvPr id="38" name="Card5"/>
+          <p:cNvPr id="41" name="Card5"/>
           <p:cNvSpPr/>
           <p:nvPr/>
         </p:nvSpPr>
@@ -2574,7 +2686,7 @@
       </p:sp>
       <p:sp>
         <p:nvSpPr>
-          <p:cNvPr id="39" name="Num5"/>
+          <p:cNvPr id="42" name="Num5"/>
           <p:cNvSpPr/>
           <p:nvPr/>
         </p:nvSpPr>
@@ -2621,7 +2733,7 @@
       </p:sp>
       <p:sp>
         <p:nvSpPr>
-          <p:cNvPr id="40" name="Card6"/>
+          <p:cNvPr id="43" name="Card6"/>
           <p:cNvSpPr/>
           <p:nvPr/>
         </p:nvSpPr>
@@ -2702,7 +2814,7 @@
       </p:sp>
       <p:sp>
         <p:nvSpPr>
-          <p:cNvPr id="41" name="Num6"/>
+          <p:cNvPr id="44" name="Num6"/>
           <p:cNvSpPr/>
           <p:nvPr/>
         </p:nvSpPr>
@@ -2786,7 +2898,7 @@
                                           </p:stCondLst>
                                         </p:cTn>
                                         <p:tgtEl>
-                                          <p:spTgt spid="30"/>
+                                          <p:spTgt spid="33"/>
                                         </p:tgtEl>
                                         <p:attrNameLst>
                                           <p:attrName>style.visibility</p:attrName>
@@ -2800,7 +2912,7 @@
                                       <p:cBhvr>
                                         <p:cTn id="6" dur="500"/>
                                         <p:tgtEl>
-                                          <p:spTgt spid="30"/>
+                                          <p:spTgt spid="33"/>
                                         </p:tgtEl>
                                       </p:cBhvr>
                                     </p:animEffect>
@@ -2821,7 +2933,7 @@
                                           </p:stCondLst>
                                         </p:cTn>
                                         <p:tgtEl>
-                                          <p:spTgt spid="31"/>
+                                          <p:spTgt spid="34"/>
                                         </p:tgtEl>
                                         <p:attrNameLst>
                                           <p:attrName>style.visibility</p:attrName>
@@ -2835,7 +2947,7 @@
                                       <p:cBhvr>
                                         <p:cTn id="9" dur="500"/>
                                         <p:tgtEl>
-                                          <p:spTgt spid="31"/>
+                                          <p:spTgt spid="34"/>
                                         </p:tgtEl>
                                       </p:cBhvr>
                                     </p:animEffect>
@@ -2856,7 +2968,7 @@
                                           </p:stCondLst>
                                         </p:cTn>
                                         <p:tgtEl>
-                                          <p:spTgt spid="24"/>
+                                          <p:spTgt spid="27"/>
                                         </p:tgtEl>
                                         <p:attrNameLst>
                                           <p:attrName>style.visibility</p:attrName>
@@ -2870,7 +2982,7 @@
                                       <p:cBhvr>
                                         <p:cTn id="12" dur="500"/>
                                         <p:tgtEl>
-                                          <p:spTgt spid="24"/>
+                                          <p:spTgt spid="27"/>
                                         </p:tgtEl>
                                       </p:cBhvr>
                                     </p:animEffect>
@@ -2909,7 +3021,7 @@
                                           </p:stCondLst>
                                         </p:cTn>
                                         <p:tgtEl>
-                                          <p:spTgt spid="32"/>
+                                          <p:spTgt spid="35"/>
                                         </p:tgtEl>
                                         <p:attrNameLst>
                                           <p:attrName>style.visibility</p:attrName>
@@ -2923,7 +3035,7 @@
                                       <p:cBhvr>
                                         <p:cTn id="17" dur="500"/>
                                         <p:tgtEl>
-                                          <p:spTgt spid="32"/>
+                                          <p:spTgt spid="35"/>
                                         </p:tgtEl>
                                       </p:cBhvr>
                                     </p:animEffect>
@@ -2944,7 +3056,7 @@
                                           </p:stCondLst>
                                         </p:cTn>
                                         <p:tgtEl>
-                                          <p:spTgt spid="33"/>
+                                          <p:spTgt spid="36"/>
                                         </p:tgtEl>
                                         <p:attrNameLst>
                                           <p:attrName>style.visibility</p:attrName>
@@ -2958,7 +3070,7 @@
                                       <p:cBhvr>
                                         <p:cTn id="20" dur="500"/>
                                         <p:tgtEl>
-                                          <p:spTgt spid="33"/>
+                                          <p:spTgt spid="36"/>
                                         </p:tgtEl>
                                       </p:cBhvr>
                                     </p:animEffect>
@@ -2979,7 +3091,7 @@
                                           </p:stCondLst>
                                         </p:cTn>
                                         <p:tgtEl>
-                                          <p:spTgt spid="26"/>
+                                          <p:spTgt spid="29"/>
                                         </p:tgtEl>
                                         <p:attrNameLst>
                                           <p:attrName>style.visibility</p:attrName>
@@ -2993,7 +3105,7 @@
                                       <p:cBhvr>
                                         <p:cTn id="23" dur="500"/>
                                         <p:tgtEl>
-                                          <p:spTgt spid="26"/>
+                                          <p:spTgt spid="29"/>
                                         </p:tgtEl>
                                       </p:cBhvr>
                                     </p:animEffect>
@@ -3032,7 +3144,7 @@
                                           </p:stCondLst>
                                         </p:cTn>
                                         <p:tgtEl>
-                                          <p:spTgt spid="34"/>
+                                          <p:spTgt spid="37"/>
                                         </p:tgtEl>
                                         <p:attrNameLst>
                                           <p:attrName>style.visibility</p:attrName>
@@ -3046,7 +3158,7 @@
                                       <p:cBhvr>
                                         <p:cTn id="28" dur="500"/>
                                         <p:tgtEl>
-                                          <p:spTgt spid="34"/>
+                                          <p:spTgt spid="37"/>
                                         </p:tgtEl>
                                       </p:cBhvr>
                                     </p:animEffect>
@@ -3067,7 +3179,7 @@
                                           </p:stCondLst>
                                         </p:cTn>
                                         <p:tgtEl>
-                                          <p:spTgt spid="35"/>
+                                          <p:spTgt spid="38"/>
                                         </p:tgtEl>
                                         <p:attrNameLst>
                                           <p:attrName>style.visibility</p:attrName>
@@ -3081,7 +3193,7 @@
                                       <p:cBhvr>
                                         <p:cTn id="31" dur="500"/>
                                         <p:tgtEl>
-                                          <p:spTgt spid="35"/>
+                                          <p:spTgt spid="38"/>
                                         </p:tgtEl>
                                       </p:cBhvr>
                                     </p:animEffect>
@@ -3102,7 +3214,7 @@
                                           </p:stCondLst>
                                         </p:cTn>
                                         <p:tgtEl>
-                                          <p:spTgt spid="25"/>
+                                          <p:spTgt spid="28"/>
                                         </p:tgtEl>
                                         <p:attrNameLst>
                                           <p:attrName>style.visibility</p:attrName>
@@ -3116,7 +3228,7 @@
                                       <p:cBhvr>
                                         <p:cTn id="34" dur="500"/>
                                         <p:tgtEl>
-                                          <p:spTgt spid="25"/>
+                                          <p:spTgt spid="28"/>
                                         </p:tgtEl>
                                       </p:cBhvr>
                                     </p:animEffect>
@@ -3155,7 +3267,7 @@
                                           </p:stCondLst>
                                         </p:cTn>
                                         <p:tgtEl>
-                                          <p:spTgt spid="36"/>
+                                          <p:spTgt spid="39"/>
                                         </p:tgtEl>
                                         <p:attrNameLst>
                                           <p:attrName>style.visibility</p:attrName>
@@ -3169,7 +3281,7 @@
                                       <p:cBhvr>
                                         <p:cTn id="39" dur="500"/>
                                         <p:tgtEl>
-                                          <p:spTgt spid="36"/>
+                                          <p:spTgt spid="39"/>
                                         </p:tgtEl>
                                       </p:cBhvr>
                                     </p:animEffect>
@@ -3190,7 +3302,7 @@
                                           </p:stCondLst>
                                         </p:cTn>
                                         <p:tgtEl>
-                                          <p:spTgt spid="37"/>
+                                          <p:spTgt spid="40"/>
                                         </p:tgtEl>
                                         <p:attrNameLst>
                                           <p:attrName>style.visibility</p:attrName>
@@ -3204,7 +3316,7 @@
                                       <p:cBhvr>
                                         <p:cTn id="42" dur="500"/>
                                         <p:tgtEl>
-                                          <p:spTgt spid="37"/>
+                                          <p:spTgt spid="40"/>
                                         </p:tgtEl>
                                       </p:cBhvr>
                                     </p:animEffect>
@@ -3225,7 +3337,7 @@
                                           </p:stCondLst>
                                         </p:cTn>
                                         <p:tgtEl>
-                                          <p:spTgt spid="27"/>
+                                          <p:spTgt spid="30"/>
                                         </p:tgtEl>
                                         <p:attrNameLst>
                                           <p:attrName>style.visibility</p:attrName>
@@ -3239,7 +3351,7 @@
                                       <p:cBhvr>
                                         <p:cTn id="45" dur="500"/>
                                         <p:tgtEl>
-                                          <p:spTgt spid="27"/>
+                                          <p:spTgt spid="30"/>
                                         </p:tgtEl>
                                       </p:cBhvr>
                                     </p:animEffect>
@@ -3278,7 +3390,7 @@
                                           </p:stCondLst>
                                         </p:cTn>
                                         <p:tgtEl>
-                                          <p:spTgt spid="38"/>
+                                          <p:spTgt spid="41"/>
                                         </p:tgtEl>
                                         <p:attrNameLst>
                                           <p:attrName>style.visibility</p:attrName>
@@ -3292,7 +3404,7 @@
                                       <p:cBhvr>
                                         <p:cTn id="50" dur="500"/>
                                         <p:tgtEl>
-                                          <p:spTgt spid="38"/>
+                                          <p:spTgt spid="41"/>
                                         </p:tgtEl>
                                       </p:cBhvr>
                                     </p:animEffect>
@@ -3313,7 +3425,7 @@
                                           </p:stCondLst>
                                         </p:cTn>
                                         <p:tgtEl>
-                                          <p:spTgt spid="39"/>
+                                          <p:spTgt spid="42"/>
                                         </p:tgtEl>
                                         <p:attrNameLst>
                                           <p:attrName>style.visibility</p:attrName>
@@ -3327,7 +3439,7 @@
                                       <p:cBhvr>
                                         <p:cTn id="53" dur="500"/>
                                         <p:tgtEl>
-                                          <p:spTgt spid="39"/>
+                                          <p:spTgt spid="42"/>
                                         </p:tgtEl>
                                       </p:cBhvr>
                                     </p:animEffect>
@@ -3348,7 +3460,7 @@
                                           </p:stCondLst>
                                         </p:cTn>
                                         <p:tgtEl>
-                                          <p:spTgt spid="28"/>
+                                          <p:spTgt spid="31"/>
                                         </p:tgtEl>
                                         <p:attrNameLst>
                                           <p:attrName>style.visibility</p:attrName>
@@ -3362,7 +3474,7 @@
                                       <p:cBhvr>
                                         <p:cTn id="56" dur="500"/>
                                         <p:tgtEl>
-                                          <p:spTgt spid="28"/>
+                                          <p:spTgt spid="31"/>
                                         </p:tgtEl>
                                       </p:cBhvr>
                                     </p:animEffect>
@@ -3401,7 +3513,7 @@
                                           </p:stCondLst>
                                         </p:cTn>
                                         <p:tgtEl>
-                                          <p:spTgt spid="40"/>
+                                          <p:spTgt spid="43"/>
                                         </p:tgtEl>
                                         <p:attrNameLst>
                                           <p:attrName>style.visibility</p:attrName>
@@ -3415,7 +3527,7 @@
                                       <p:cBhvr>
                                         <p:cTn id="61" dur="500"/>
                                         <p:tgtEl>
-                                          <p:spTgt spid="40"/>
+                                          <p:spTgt spid="43"/>
                                         </p:tgtEl>
                                       </p:cBhvr>
                                     </p:animEffect>
@@ -3436,7 +3548,7 @@
                                           </p:stCondLst>
                                         </p:cTn>
                                         <p:tgtEl>
-                                          <p:spTgt spid="41"/>
+                                          <p:spTgt spid="44"/>
                                         </p:tgtEl>
                                         <p:attrNameLst>
                                           <p:attrName>style.visibility</p:attrName>
@@ -3450,7 +3562,7 @@
                                       <p:cBhvr>
                                         <p:cTn id="64" dur="500"/>
                                         <p:tgtEl>
-                                          <p:spTgt spid="41"/>
+                                          <p:spTgt spid="44"/>
                                         </p:tgtEl>
                                       </p:cBhvr>
                                     </p:animEffect>
@@ -3471,7 +3583,7 @@
                                           </p:stCondLst>
                                         </p:cTn>
                                         <p:tgtEl>
-                                          <p:spTgt spid="29"/>
+                                          <p:spTgt spid="32"/>
                                         </p:tgtEl>
                                         <p:attrNameLst>
                                           <p:attrName>style.visibility</p:attrName>
@@ -3485,7 +3597,7 @@
                                       <p:cBhvr>
                                         <p:cTn id="67" dur="500"/>
                                         <p:tgtEl>
-                                          <p:spTgt spid="29"/>
+                                          <p:spTgt spid="32"/>
                                         </p:tgtEl>
                                       </p:cBhvr>
                                     </p:animEffect>
@@ -3520,24 +3632,24 @@
       </p:par>
     </p:tnLst>
     <p:bldLst>
+      <p:bldP spid="33" grpId="0" animBg="1"/>
+      <p:bldP spid="34" grpId="0" animBg="1"/>
+      <p:bldP spid="27" grpId="0" animBg="1"/>
+      <p:bldP spid="35" grpId="0" animBg="1"/>
+      <p:bldP spid="36" grpId="0" animBg="1"/>
+      <p:bldP spid="29" grpId="0" animBg="1"/>
+      <p:bldP spid="37" grpId="0" animBg="1"/>
+      <p:bldP spid="38" grpId="0" animBg="1"/>
+      <p:bldP spid="28" grpId="0" animBg="1"/>
+      <p:bldP spid="39" grpId="0" animBg="1"/>
+      <p:bldP spid="40" grpId="0" animBg="1"/>
       <p:bldP spid="30" grpId="0" animBg="1"/>
+      <p:bldP spid="41" grpId="0" animBg="1"/>
+      <p:bldP spid="42" grpId="0" animBg="1"/>
       <p:bldP spid="31" grpId="0" animBg="1"/>
-      <p:bldP spid="24" grpId="0" animBg="1"/>
+      <p:bldP spid="43" grpId="0" animBg="1"/>
+      <p:bldP spid="44" grpId="0" animBg="1"/>
       <p:bldP spid="32" grpId="0" animBg="1"/>
-      <p:bldP spid="33" grpId="0" animBg="1"/>
-      <p:bldP spid="26" grpId="0" animBg="1"/>
-      <p:bldP spid="34" grpId="0" animBg="1"/>
-      <p:bldP spid="35" grpId="0" animBg="1"/>
-      <p:bldP spid="25" grpId="0" animBg="1"/>
-      <p:bldP spid="36" grpId="0" animBg="1"/>
-      <p:bldP spid="37" grpId="0" animBg="1"/>
-      <p:bldP spid="27" grpId="0" animBg="1"/>
-      <p:bldP spid="38" grpId="0" animBg="1"/>
-      <p:bldP spid="39" grpId="0" animBg="1"/>
-      <p:bldP spid="28" grpId="0" animBg="1"/>
-      <p:bldP spid="40" grpId="0" animBg="1"/>
-      <p:bldP spid="41" grpId="0" animBg="1"/>
-      <p:bldP spid="29" grpId="0" animBg="1"/>
     </p:bldLst>
   </p:timing>
 </p:sld>

</xml_diff>